<commit_message>
feat: add one-slide agent architecture
</commit_message>
<xml_diff>
--- a/docs/FirstCheck24_Hackathon_Pitch.pptx
+++ b/docs/FirstCheck24_Hackathon_Pitch.pptx
@@ -1215,7 +1215,7 @@
           <a:p>
             <a:r>
               <a:rPr lang="en-US" dirty="0"/>
-              <a:t>Our frontend is built with React and TypeScript, while FastAPI runs the core workflow. Redis and ARQ handle asynchronous collection, Postgres and pgvector store identities, evidence graphs, and scores, and MinIO preserves source artifacts. The full system runs in Docker with versioned evidence and scoring.</a:t>
+              <a:t>FirstCheck24 runs one evidence pipeline with two connected entry paths. Outbound starts from the fund thesis. A discovery agent scans public sources, creates an initial signal score, and places high-potential founders in a promising queue. A footprint agent then resolves identity and gathers deeper technical, company, and network evidence. The three-axis engine scores Founder, Market, and Idea–Market Fit independently, including trends, confidence, and SWOT. If the case is strong, the outreach agent drafts a personalized message, with the investor approving the send. When a founder applies inbound and uploads a deck, the deck agent extracts claims and adds them to the same evidence graph. The system re-scores the opportunity, highlights contradictions, and produces an explainable recommendation: proceed, hold, or decline. Every human decision feeds memory and improves the next search.</a:t>
             </a:r>
             <a:endParaRPr lang="en-US" dirty="0"/>
           </a:p>
@@ -11145,7 +11145,7 @@
         <p:spPr>
           <a:xfrm>
             <a:off x="685800" y="548640"/>
-            <a:ext cx="5791200" cy="213360"/>
+            <a:ext cx="9448800" cy="213360"/>
           </a:xfrm>
           <a:prstGeom prst="rect">
             <a:avLst/>
@@ -11171,7 +11171,7 @@
                 <a:ea typeface="Aptos" pitchFamily="34" charset="-122"/>
                 <a:cs typeface="Aptos" pitchFamily="34" charset="-120"/>
               </a:rPr>
-              <a:t>BUILT TO SHIP</a:t>
+              <a:t>AGENT ARCHITECTURE</a:t>
             </a:r>
             <a:endParaRPr lang="en-US" sz="900" dirty="0"/>
           </a:p>
@@ -11186,7 +11186,7 @@
         <p:spPr>
           <a:xfrm>
             <a:off x="685800" y="800100"/>
-            <a:ext cx="5791200" cy="760781"/>
+            <a:ext cx="9448800" cy="348691"/>
           </a:xfrm>
           <a:prstGeom prst="rect">
             <a:avLst/>
@@ -11204,7 +11204,7 @@
               <a:buNone/>
             </a:pPr>
             <a:r>
-              <a:rPr lang="en-US" sz="2880" b="1" dirty="0">
+              <a:rPr lang="en-US" sz="2640" b="1" dirty="0">
                 <a:solidFill>
                   <a:srgbClr val="172337"/>
                 </a:solidFill>
@@ -11212,26 +11212,9 @@
                 <a:ea typeface="Aptos Display" pitchFamily="34" charset="-122"/>
                 <a:cs typeface="Aptos Display" pitchFamily="34" charset="-120"/>
               </a:rPr>
-              <a:t>Implementation that</a:t>
-            </a:r>
-            <a:endParaRPr lang="en-US" sz="2880" dirty="0"/>
-          </a:p>
-          <a:p>
-            <a:pPr algn="l" indent="0" marL="0">
-              <a:buNone/>
-            </a:pPr>
-            <a:r>
-              <a:rPr lang="en-US" sz="2880" b="1" dirty="0">
-                <a:solidFill>
-                  <a:srgbClr val="172337"/>
-                </a:solidFill>
-                <a:latin typeface="Aptos Display" pitchFamily="34" charset="0"/>
-                <a:ea typeface="Aptos Display" pitchFamily="34" charset="-122"/>
-                <a:cs typeface="Aptos Display" pitchFamily="34" charset="-120"/>
-              </a:rPr>
-              <a:t>matches the promise.</a:t>
-            </a:r>
-            <a:endParaRPr lang="en-US" sz="2880" dirty="0"/>
+              <a:t>Two entry paths. One evidence pipeline.</a:t>
+            </a:r>
+            <a:endParaRPr lang="en-US" sz="2640" dirty="0"/>
           </a:p>
         </p:txBody>
       </p:sp>
@@ -11243,36 +11226,36 @@
         </p:nvSpPr>
         <p:spPr>
           <a:xfrm>
-            <a:off x="685800" y="1866900"/>
-            <a:ext cx="1981200" cy="198120"/>
-          </a:xfrm>
-          <a:prstGeom prst="rect">
-            <a:avLst/>
-          </a:prstGeom>
-          <a:noFill/>
-          <a:ln/>
-        </p:spPr>
-        <p:txBody>
-          <a:bodyPr wrap="square" lIns="0" tIns="0" rIns="0" bIns="0" rtlCol="0" anchor="ctr">
-            <a:normAutofit/>
-          </a:bodyPr>
-          <a:lstStyle/>
-          <a:p>
-            <a:pPr algn="l" indent="0" marL="0">
-              <a:buNone/>
-            </a:pPr>
-            <a:r>
-              <a:rPr lang="en-US" sz="720" b="1" spc="180" kern="0" dirty="0">
-                <a:solidFill>
-                  <a:srgbClr val="557DC0"/>
-                </a:solidFill>
-                <a:latin typeface="Aptos" pitchFamily="34" charset="0"/>
-                <a:ea typeface="Aptos" pitchFamily="34" charset="-122"/>
-                <a:cs typeface="Aptos" pitchFamily="34" charset="-120"/>
-              </a:rPr>
-              <a:t>TECH STACK</a:t>
-            </a:r>
-            <a:endParaRPr lang="en-US" sz="720" dirty="0"/>
+            <a:off x="685800" y="1278331"/>
+            <a:ext cx="10058400" cy="243840"/>
+          </a:xfrm>
+          <a:prstGeom prst="rect">
+            <a:avLst/>
+          </a:prstGeom>
+          <a:noFill/>
+          <a:ln/>
+        </p:spPr>
+        <p:txBody>
+          <a:bodyPr wrap="square" lIns="0" tIns="0" rIns="0" bIns="0" rtlCol="0" anchor="t">
+            <a:normAutofit/>
+          </a:bodyPr>
+          <a:lstStyle/>
+          <a:p>
+            <a:pPr algn="l" indent="0" marL="0">
+              <a:buNone/>
+            </a:pPr>
+            <a:r>
+              <a:rPr lang="en-US" sz="1200" dirty="0">
+                <a:solidFill>
+                  <a:srgbClr val="718097"/>
+                </a:solidFill>
+                <a:latin typeface="Aptos" pitchFamily="34" charset="0"/>
+                <a:ea typeface="Aptos" pitchFamily="34" charset="-122"/>
+                <a:cs typeface="Aptos" pitchFamily="34" charset="-120"/>
+              </a:rPr>
+              <a:t>Outbound discovers hidden founders. Inbound turns applications and decks into structured evidence.</a:t>
+            </a:r>
+            <a:endParaRPr lang="en-US" sz="1200" dirty="0"/>
           </a:p>
         </p:txBody>
       </p:sp>
@@ -11284,12 +11267,12 @@
         </p:nvSpPr>
         <p:spPr>
           <a:xfrm>
-            <a:off x="685800" y="2133600"/>
-            <a:ext cx="3581400" cy="518160"/>
+            <a:off x="685800" y="1874520"/>
+            <a:ext cx="1866900" cy="266700"/>
           </a:xfrm>
           <a:prstGeom prst="roundRect">
             <a:avLst>
-              <a:gd name="adj" fmla="val 21176"/>
+              <a:gd name="adj" fmla="val 54857"/>
             </a:avLst>
           </a:prstGeom>
           <a:solidFill>
@@ -11313,26 +11296,26 @@
         </p:nvSpPr>
         <p:spPr>
           <a:xfrm>
-            <a:off x="876300" y="2194560"/>
-            <a:ext cx="1943100" cy="205740"/>
-          </a:xfrm>
-          <a:prstGeom prst="rect">
-            <a:avLst/>
-          </a:prstGeom>
-          <a:noFill/>
-          <a:ln/>
-        </p:spPr>
-        <p:txBody>
-          <a:bodyPr wrap="square" lIns="0" tIns="0" rIns="0" bIns="0" rtlCol="0" anchor="ctr">
-            <a:normAutofit/>
-          </a:bodyPr>
-          <a:lstStyle/>
-          <a:p>
-            <a:pPr algn="l" indent="0" marL="0">
-              <a:buNone/>
-            </a:pPr>
-            <a:r>
-              <a:rPr lang="en-US" sz="960" b="1" dirty="0">
+            <a:off x="762000" y="1897380"/>
+            <a:ext cx="1714500" cy="220980"/>
+          </a:xfrm>
+          <a:prstGeom prst="rect">
+            <a:avLst/>
+          </a:prstGeom>
+          <a:noFill/>
+          <a:ln/>
+        </p:spPr>
+        <p:txBody>
+          <a:bodyPr wrap="square" lIns="0" tIns="0" rIns="0" bIns="0" rtlCol="0" anchor="ctr">
+            <a:normAutofit/>
+          </a:bodyPr>
+          <a:lstStyle/>
+          <a:p>
+            <a:pPr algn="ctr" indent="0" marL="0">
+              <a:buNone/>
+            </a:pPr>
+            <a:r>
+              <a:rPr lang="en-US" sz="600" b="1" spc="30" kern="0" dirty="0">
                 <a:solidFill>
                   <a:srgbClr val="557DC0"/>
                 </a:solidFill>
@@ -11340,52 +11323,40 @@
                 <a:ea typeface="Aptos" pitchFamily="34" charset="-122"/>
                 <a:cs typeface="Aptos" pitchFamily="34" charset="-120"/>
               </a:rPr>
-              <a:t>React + TypeScript</a:t>
-            </a:r>
-            <a:endParaRPr lang="en-US" sz="960" dirty="0"/>
-          </a:p>
-        </p:txBody>
-      </p:sp>
-      <p:sp>
-        <p:nvSpPr>
-          <p:cNvPr id="7" name="Text 5"/>
-          <p:cNvSpPr txBox="1"/>
-          <p:nvPr/>
-        </p:nvSpPr>
-        <p:spPr>
-          <a:xfrm>
-            <a:off x="2819400" y="2209800"/>
-            <a:ext cx="1219200" cy="182880"/>
-          </a:xfrm>
-          <a:prstGeom prst="rect">
-            <a:avLst/>
-          </a:prstGeom>
-          <a:noFill/>
-          <a:ln/>
-        </p:spPr>
-        <p:txBody>
-          <a:bodyPr wrap="square" lIns="0" tIns="0" rIns="0" bIns="0" rtlCol="0" anchor="ctr">
-            <a:normAutofit/>
-          </a:bodyPr>
-          <a:lstStyle/>
-          <a:p>
-            <a:pPr algn="r" indent="0" marL="0">
-              <a:buNone/>
-            </a:pPr>
-            <a:r>
-              <a:rPr lang="en-US" sz="720" b="1" dirty="0">
-                <a:solidFill>
-                  <a:srgbClr val="718097"/>
-                </a:solidFill>
-                <a:latin typeface="Aptos" pitchFamily="34" charset="0"/>
-                <a:ea typeface="Aptos" pitchFamily="34" charset="-122"/>
-                <a:cs typeface="Aptos" pitchFamily="34" charset="-120"/>
-              </a:rPr>
-              <a:t>Investor SPA</a:t>
-            </a:r>
-            <a:endParaRPr lang="en-US" sz="720" dirty="0"/>
-          </a:p>
-        </p:txBody>
+              <a:t>OUTBOUND · PROACTIVE</a:t>
+            </a:r>
+            <a:endParaRPr lang="en-US" sz="600" dirty="0"/>
+          </a:p>
+        </p:txBody>
+      </p:sp>
+      <p:sp>
+        <p:nvSpPr>
+          <p:cNvPr id="7" name="Shape 5"/>
+          <p:cNvSpPr/>
+          <p:nvPr/>
+        </p:nvSpPr>
+        <p:spPr>
+          <a:xfrm>
+            <a:off x="685800" y="2286000"/>
+            <a:ext cx="1600200" cy="883920"/>
+          </a:xfrm>
+          <a:prstGeom prst="roundRect">
+            <a:avLst>
+              <a:gd name="adj" fmla="val 14483"/>
+            </a:avLst>
+          </a:prstGeom>
+          <a:solidFill>
+            <a:srgbClr val="E7EEF9"/>
+          </a:solidFill>
+          <a:ln w="6350">
+            <a:solidFill>
+              <a:srgbClr val="E7EEF9">
+                <a:alpha val="0"/>
+              </a:srgbClr>
+            </a:solidFill>
+            <a:prstDash val="solid"/>
+          </a:ln>
+        </p:spPr>
       </p:sp>
       <p:sp>
         <p:nvSpPr>
@@ -11395,37 +11366,189 @@
         </p:nvSpPr>
         <p:spPr>
           <a:xfrm>
-            <a:off x="2476500" y="2651760"/>
-            <a:ext cx="0" cy="175260"/>
+            <a:off x="807720" y="2400300"/>
+            <a:ext cx="320040" cy="213360"/>
+          </a:xfrm>
+          <a:prstGeom prst="roundRect">
+            <a:avLst>
+              <a:gd name="adj" fmla="val 68571"/>
+            </a:avLst>
+          </a:prstGeom>
+          <a:solidFill>
+            <a:srgbClr val="FFFFFF"/>
+          </a:solidFill>
+          <a:ln w="6350">
+            <a:solidFill>
+              <a:srgbClr val="FFFFFF">
+                <a:alpha val="0"/>
+              </a:srgbClr>
+            </a:solidFill>
+            <a:prstDash val="solid"/>
+          </a:ln>
+        </p:spPr>
+      </p:sp>
+      <p:sp>
+        <p:nvSpPr>
+          <p:cNvPr id="9" name="Text 7"/>
+          <p:cNvSpPr txBox="1"/>
+          <p:nvPr/>
+        </p:nvSpPr>
+        <p:spPr>
+          <a:xfrm>
+            <a:off x="883920" y="2423160"/>
+            <a:ext cx="167640" cy="167640"/>
+          </a:xfrm>
+          <a:prstGeom prst="rect">
+            <a:avLst/>
+          </a:prstGeom>
+          <a:noFill/>
+          <a:ln/>
+        </p:spPr>
+        <p:txBody>
+          <a:bodyPr wrap="square" lIns="0" tIns="0" rIns="0" bIns="0" rtlCol="0" anchor="ctr">
+            <a:normAutofit/>
+          </a:bodyPr>
+          <a:lstStyle/>
+          <a:p>
+            <a:pPr algn="ctr" indent="0" marL="0">
+              <a:buNone/>
+            </a:pPr>
+            <a:r>
+              <a:rPr lang="en-US" sz="540" b="1" spc="30" kern="0" dirty="0">
+                <a:solidFill>
+                  <a:srgbClr val="557DC0"/>
+                </a:solidFill>
+                <a:latin typeface="Aptos" pitchFamily="34" charset="0"/>
+                <a:ea typeface="Aptos" pitchFamily="34" charset="-122"/>
+                <a:cs typeface="Aptos" pitchFamily="34" charset="-120"/>
+              </a:rPr>
+              <a:t>01</a:t>
+            </a:r>
+            <a:endParaRPr lang="en-US" sz="540" dirty="0"/>
+          </a:p>
+        </p:txBody>
+      </p:sp>
+      <p:sp>
+        <p:nvSpPr>
+          <p:cNvPr id="10" name="Text 8"/>
+          <p:cNvSpPr txBox="1"/>
+          <p:nvPr/>
+        </p:nvSpPr>
+        <p:spPr>
+          <a:xfrm>
+            <a:off x="807720" y="2674620"/>
+            <a:ext cx="1356360" cy="175260"/>
+          </a:xfrm>
+          <a:prstGeom prst="rect">
+            <a:avLst/>
+          </a:prstGeom>
+          <a:noFill/>
+          <a:ln/>
+        </p:spPr>
+        <p:txBody>
+          <a:bodyPr wrap="square" lIns="0" tIns="0" rIns="0" bIns="0" rtlCol="0" anchor="ctr">
+            <a:normAutofit/>
+          </a:bodyPr>
+          <a:lstStyle/>
+          <a:p>
+            <a:pPr algn="l" indent="0" marL="0">
+              <a:buNone/>
+            </a:pPr>
+            <a:r>
+              <a:rPr lang="en-US" sz="780" b="1" spc="80" kern="0" dirty="0">
+                <a:solidFill>
+                  <a:srgbClr val="557DC0"/>
+                </a:solidFill>
+                <a:latin typeface="Aptos" pitchFamily="34" charset="0"/>
+                <a:ea typeface="Aptos" pitchFamily="34" charset="-122"/>
+                <a:cs typeface="Aptos" pitchFamily="34" charset="-120"/>
+              </a:rPr>
+              <a:t>DISCOVER</a:t>
+            </a:r>
+            <a:endParaRPr lang="en-US" sz="780" dirty="0"/>
+          </a:p>
+        </p:txBody>
+      </p:sp>
+      <p:sp>
+        <p:nvSpPr>
+          <p:cNvPr id="11" name="Text 9"/>
+          <p:cNvSpPr txBox="1"/>
+          <p:nvPr/>
+        </p:nvSpPr>
+        <p:spPr>
+          <a:xfrm>
+            <a:off x="807720" y="2895600"/>
+            <a:ext cx="1356360" cy="167640"/>
+          </a:xfrm>
+          <a:prstGeom prst="rect">
+            <a:avLst/>
+          </a:prstGeom>
+          <a:noFill/>
+          <a:ln/>
+        </p:spPr>
+        <p:txBody>
+          <a:bodyPr wrap="square" lIns="0" tIns="0" rIns="0" bIns="0" rtlCol="0" anchor="ctr">
+            <a:normAutofit/>
+          </a:bodyPr>
+          <a:lstStyle/>
+          <a:p>
+            <a:pPr algn="l" indent="0" marL="0">
+              <a:buNone/>
+            </a:pPr>
+            <a:r>
+              <a:rPr lang="en-US" sz="660" b="1" dirty="0">
+                <a:solidFill>
+                  <a:srgbClr val="344258"/>
+                </a:solidFill>
+                <a:latin typeface="Aptos" pitchFamily="34" charset="0"/>
+                <a:ea typeface="Aptos" pitchFamily="34" charset="-122"/>
+                <a:cs typeface="Aptos" pitchFamily="34" charset="-120"/>
+              </a:rPr>
+              <a:t>Thesis + public signals</a:t>
+            </a:r>
+            <a:endParaRPr lang="en-US" sz="660" dirty="0"/>
+          </a:p>
+        </p:txBody>
+      </p:sp>
+      <p:sp>
+        <p:nvSpPr>
+          <p:cNvPr id="12" name="Shape 10"/>
+          <p:cNvSpPr/>
+          <p:nvPr/>
+        </p:nvSpPr>
+        <p:spPr>
+          <a:xfrm>
+            <a:off x="2308860" y="2727960"/>
+            <a:ext cx="213360" cy="0"/>
           </a:xfrm>
           <a:prstGeom prst="line">
             <a:avLst/>
           </a:prstGeom>
           <a:noFill/>
-          <a:ln w="25400">
+          <a:ln w="22860">
             <a:solidFill>
-              <a:srgbClr val="DCE5F0"/>
+              <a:srgbClr val="557DC0"/>
             </a:solidFill>
             <a:prstDash val="solid"/>
             <a:headEnd type="none"/>
-            <a:tailEnd type="none"/>
+            <a:tailEnd type="triangle"/>
           </a:ln>
         </p:spPr>
       </p:sp>
       <p:sp>
         <p:nvSpPr>
-          <p:cNvPr id="9" name="Shape 7"/>
-          <p:cNvSpPr/>
-          <p:nvPr/>
-        </p:nvSpPr>
-        <p:spPr>
-          <a:xfrm>
-            <a:off x="685800" y="2827020"/>
-            <a:ext cx="3581400" cy="518160"/>
+          <p:cNvPr id="13" name="Shape 11"/>
+          <p:cNvSpPr/>
+          <p:nvPr/>
+        </p:nvSpPr>
+        <p:spPr>
+          <a:xfrm>
+            <a:off x="2552700" y="2286000"/>
+            <a:ext cx="1600200" cy="883920"/>
           </a:xfrm>
           <a:prstGeom prst="roundRect">
             <a:avLst>
-              <a:gd name="adj" fmla="val 21176"/>
+              <a:gd name="adj" fmla="val 14483"/>
             </a:avLst>
           </a:prstGeom>
           <a:solidFill>
@@ -11443,32 +11566,61 @@
       </p:sp>
       <p:sp>
         <p:nvSpPr>
-          <p:cNvPr id="10" name="Text 8"/>
-          <p:cNvSpPr txBox="1"/>
-          <p:nvPr/>
-        </p:nvSpPr>
-        <p:spPr>
-          <a:xfrm>
-            <a:off x="876300" y="2887980"/>
-            <a:ext cx="1943100" cy="205740"/>
-          </a:xfrm>
-          <a:prstGeom prst="rect">
-            <a:avLst/>
-          </a:prstGeom>
-          <a:noFill/>
-          <a:ln/>
-        </p:spPr>
-        <p:txBody>
-          <a:bodyPr wrap="square" lIns="0" tIns="0" rIns="0" bIns="0" rtlCol="0" anchor="ctr">
-            <a:normAutofit/>
-          </a:bodyPr>
-          <a:lstStyle/>
-          <a:p>
-            <a:pPr algn="l" indent="0" marL="0">
-              <a:buNone/>
-            </a:pPr>
-            <a:r>
-              <a:rPr lang="en-US" sz="960" b="1" dirty="0">
+          <p:cNvPr id="14" name="Shape 12"/>
+          <p:cNvSpPr/>
+          <p:nvPr/>
+        </p:nvSpPr>
+        <p:spPr>
+          <a:xfrm>
+            <a:off x="2674620" y="2400300"/>
+            <a:ext cx="320040" cy="213360"/>
+          </a:xfrm>
+          <a:prstGeom prst="roundRect">
+            <a:avLst>
+              <a:gd name="adj" fmla="val 68571"/>
+            </a:avLst>
+          </a:prstGeom>
+          <a:solidFill>
+            <a:srgbClr val="FFFFFF"/>
+          </a:solidFill>
+          <a:ln w="6350">
+            <a:solidFill>
+              <a:srgbClr val="FFFFFF">
+                <a:alpha val="0"/>
+              </a:srgbClr>
+            </a:solidFill>
+            <a:prstDash val="solid"/>
+          </a:ln>
+        </p:spPr>
+      </p:sp>
+      <p:sp>
+        <p:nvSpPr>
+          <p:cNvPr id="15" name="Text 13"/>
+          <p:cNvSpPr txBox="1"/>
+          <p:nvPr/>
+        </p:nvSpPr>
+        <p:spPr>
+          <a:xfrm>
+            <a:off x="2750820" y="2423160"/>
+            <a:ext cx="167640" cy="167640"/>
+          </a:xfrm>
+          <a:prstGeom prst="rect">
+            <a:avLst/>
+          </a:prstGeom>
+          <a:noFill/>
+          <a:ln/>
+        </p:spPr>
+        <p:txBody>
+          <a:bodyPr wrap="square" lIns="0" tIns="0" rIns="0" bIns="0" rtlCol="0" anchor="ctr">
+            <a:normAutofit/>
+          </a:bodyPr>
+          <a:lstStyle/>
+          <a:p>
+            <a:pPr algn="ctr" indent="0" marL="0">
+              <a:buNone/>
+            </a:pPr>
+            <a:r>
+              <a:rPr lang="en-US" sz="540" b="1" spc="30" kern="0" dirty="0">
                 <a:solidFill>
                   <a:srgbClr val="7656A5"/>
                 </a:solidFill>
@@ -11476,92 +11628,339 @@
                 <a:ea typeface="Aptos" pitchFamily="34" charset="-122"/>
                 <a:cs typeface="Aptos" pitchFamily="34" charset="-120"/>
               </a:rPr>
-              <a:t>FastAPI</a:t>
-            </a:r>
-            <a:endParaRPr lang="en-US" sz="960" dirty="0"/>
-          </a:p>
-        </p:txBody>
-      </p:sp>
-      <p:sp>
-        <p:nvSpPr>
-          <p:cNvPr id="11" name="Text 9"/>
-          <p:cNvSpPr txBox="1"/>
-          <p:nvPr/>
-        </p:nvSpPr>
-        <p:spPr>
-          <a:xfrm>
-            <a:off x="2819400" y="2903220"/>
-            <a:ext cx="1219200" cy="182880"/>
-          </a:xfrm>
-          <a:prstGeom prst="rect">
-            <a:avLst/>
-          </a:prstGeom>
-          <a:noFill/>
-          <a:ln/>
-        </p:spPr>
-        <p:txBody>
-          <a:bodyPr wrap="square" lIns="0" tIns="0" rIns="0" bIns="0" rtlCol="0" anchor="ctr">
-            <a:normAutofit/>
-          </a:bodyPr>
-          <a:lstStyle/>
-          <a:p>
-            <a:pPr algn="r" indent="0" marL="0">
-              <a:buNone/>
-            </a:pPr>
-            <a:r>
-              <a:rPr lang="en-US" sz="720" b="1" dirty="0">
-                <a:solidFill>
-                  <a:srgbClr val="718097"/>
-                </a:solidFill>
-                <a:latin typeface="Aptos" pitchFamily="34" charset="0"/>
-                <a:ea typeface="Aptos" pitchFamily="34" charset="-122"/>
-                <a:cs typeface="Aptos" pitchFamily="34" charset="-120"/>
-              </a:rPr>
-              <a:t>Modular API</a:t>
-            </a:r>
-            <a:endParaRPr lang="en-US" sz="720" dirty="0"/>
-          </a:p>
-        </p:txBody>
-      </p:sp>
-      <p:sp>
-        <p:nvSpPr>
-          <p:cNvPr id="12" name="Shape 10"/>
-          <p:cNvSpPr/>
-          <p:nvPr/>
-        </p:nvSpPr>
-        <p:spPr>
-          <a:xfrm>
-            <a:off x="2476500" y="3345180"/>
-            <a:ext cx="0" cy="175260"/>
+              <a:t>02</a:t>
+            </a:r>
+            <a:endParaRPr lang="en-US" sz="540" dirty="0"/>
+          </a:p>
+        </p:txBody>
+      </p:sp>
+      <p:sp>
+        <p:nvSpPr>
+          <p:cNvPr id="16" name="Text 14"/>
+          <p:cNvSpPr txBox="1"/>
+          <p:nvPr/>
+        </p:nvSpPr>
+        <p:spPr>
+          <a:xfrm>
+            <a:off x="2674620" y="2674620"/>
+            <a:ext cx="1356360" cy="175260"/>
+          </a:xfrm>
+          <a:prstGeom prst="rect">
+            <a:avLst/>
+          </a:prstGeom>
+          <a:noFill/>
+          <a:ln/>
+        </p:spPr>
+        <p:txBody>
+          <a:bodyPr wrap="square" lIns="0" tIns="0" rIns="0" bIns="0" rtlCol="0" anchor="ctr">
+            <a:normAutofit/>
+          </a:bodyPr>
+          <a:lstStyle/>
+          <a:p>
+            <a:pPr algn="l" indent="0" marL="0">
+              <a:buNone/>
+            </a:pPr>
+            <a:r>
+              <a:rPr lang="en-US" sz="780" b="1" spc="80" kern="0" dirty="0">
+                <a:solidFill>
+                  <a:srgbClr val="7656A5"/>
+                </a:solidFill>
+                <a:latin typeface="Aptos" pitchFamily="34" charset="0"/>
+                <a:ea typeface="Aptos" pitchFamily="34" charset="-122"/>
+                <a:cs typeface="Aptos" pitchFamily="34" charset="-120"/>
+              </a:rPr>
+              <a:t>SIGNAL SCORE</a:t>
+            </a:r>
+            <a:endParaRPr lang="en-US" sz="780" dirty="0"/>
+          </a:p>
+        </p:txBody>
+      </p:sp>
+      <p:sp>
+        <p:nvSpPr>
+          <p:cNvPr id="17" name="Text 15"/>
+          <p:cNvSpPr txBox="1"/>
+          <p:nvPr/>
+        </p:nvSpPr>
+        <p:spPr>
+          <a:xfrm>
+            <a:off x="2674620" y="2895600"/>
+            <a:ext cx="1356360" cy="167640"/>
+          </a:xfrm>
+          <a:prstGeom prst="rect">
+            <a:avLst/>
+          </a:prstGeom>
+          <a:noFill/>
+          <a:ln/>
+        </p:spPr>
+        <p:txBody>
+          <a:bodyPr wrap="square" lIns="0" tIns="0" rIns="0" bIns="0" rtlCol="0" anchor="ctr">
+            <a:normAutofit/>
+          </a:bodyPr>
+          <a:lstStyle/>
+          <a:p>
+            <a:pPr algn="l" indent="0" marL="0">
+              <a:buNone/>
+            </a:pPr>
+            <a:r>
+              <a:rPr lang="en-US" sz="660" b="1" dirty="0">
+                <a:solidFill>
+                  <a:srgbClr val="344258"/>
+                </a:solidFill>
+                <a:latin typeface="Aptos" pitchFamily="34" charset="0"/>
+                <a:ea typeface="Aptos" pitchFamily="34" charset="-122"/>
+                <a:cs typeface="Aptos" pitchFamily="34" charset="-120"/>
+              </a:rPr>
+              <a:t>Fast triage</a:t>
+            </a:r>
+            <a:endParaRPr lang="en-US" sz="660" dirty="0"/>
+          </a:p>
+        </p:txBody>
+      </p:sp>
+      <p:sp>
+        <p:nvSpPr>
+          <p:cNvPr id="18" name="Shape 16"/>
+          <p:cNvSpPr/>
+          <p:nvPr/>
+        </p:nvSpPr>
+        <p:spPr>
+          <a:xfrm>
+            <a:off x="4175760" y="2727960"/>
+            <a:ext cx="213360" cy="0"/>
           </a:xfrm>
           <a:prstGeom prst="line">
             <a:avLst/>
           </a:prstGeom>
           <a:noFill/>
-          <a:ln w="25400">
+          <a:ln w="22860">
             <a:solidFill>
-              <a:srgbClr val="DCE5F0"/>
+              <a:srgbClr val="7656A5"/>
             </a:solidFill>
             <a:prstDash val="solid"/>
             <a:headEnd type="none"/>
-            <a:tailEnd type="none"/>
+            <a:tailEnd type="triangle"/>
           </a:ln>
         </p:spPr>
       </p:sp>
       <p:sp>
         <p:nvSpPr>
-          <p:cNvPr id="13" name="Shape 11"/>
-          <p:cNvSpPr/>
-          <p:nvPr/>
-        </p:nvSpPr>
-        <p:spPr>
-          <a:xfrm>
-            <a:off x="685800" y="3520440"/>
-            <a:ext cx="3581400" cy="518160"/>
+          <p:cNvPr id="19" name="Shape 17"/>
+          <p:cNvSpPr/>
+          <p:nvPr/>
+        </p:nvSpPr>
+        <p:spPr>
+          <a:xfrm>
+            <a:off x="4419600" y="2286000"/>
+            <a:ext cx="1600200" cy="883920"/>
           </a:xfrm>
           <a:prstGeom prst="roundRect">
             <a:avLst>
-              <a:gd name="adj" fmla="val 21176"/>
+              <a:gd name="adj" fmla="val 14483"/>
+            </a:avLst>
+          </a:prstGeom>
+          <a:solidFill>
+            <a:srgbClr val="E4F2ED"/>
+          </a:solidFill>
+          <a:ln w="6350">
+            <a:solidFill>
+              <a:srgbClr val="E4F2ED">
+                <a:alpha val="0"/>
+              </a:srgbClr>
+            </a:solidFill>
+            <a:prstDash val="solid"/>
+          </a:ln>
+        </p:spPr>
+      </p:sp>
+      <p:sp>
+        <p:nvSpPr>
+          <p:cNvPr id="20" name="Shape 18"/>
+          <p:cNvSpPr/>
+          <p:nvPr/>
+        </p:nvSpPr>
+        <p:spPr>
+          <a:xfrm>
+            <a:off x="4541520" y="2400300"/>
+            <a:ext cx="320040" cy="213360"/>
+          </a:xfrm>
+          <a:prstGeom prst="roundRect">
+            <a:avLst>
+              <a:gd name="adj" fmla="val 68571"/>
+            </a:avLst>
+          </a:prstGeom>
+          <a:solidFill>
+            <a:srgbClr val="FFFFFF"/>
+          </a:solidFill>
+          <a:ln w="6350">
+            <a:solidFill>
+              <a:srgbClr val="FFFFFF">
+                <a:alpha val="0"/>
+              </a:srgbClr>
+            </a:solidFill>
+            <a:prstDash val="solid"/>
+          </a:ln>
+        </p:spPr>
+      </p:sp>
+      <p:sp>
+        <p:nvSpPr>
+          <p:cNvPr id="21" name="Text 19"/>
+          <p:cNvSpPr txBox="1"/>
+          <p:nvPr/>
+        </p:nvSpPr>
+        <p:spPr>
+          <a:xfrm>
+            <a:off x="4617720" y="2423160"/>
+            <a:ext cx="167640" cy="167640"/>
+          </a:xfrm>
+          <a:prstGeom prst="rect">
+            <a:avLst/>
+          </a:prstGeom>
+          <a:noFill/>
+          <a:ln/>
+        </p:spPr>
+        <p:txBody>
+          <a:bodyPr wrap="square" lIns="0" tIns="0" rIns="0" bIns="0" rtlCol="0" anchor="ctr">
+            <a:normAutofit/>
+          </a:bodyPr>
+          <a:lstStyle/>
+          <a:p>
+            <a:pPr algn="ctr" indent="0" marL="0">
+              <a:buNone/>
+            </a:pPr>
+            <a:r>
+              <a:rPr lang="en-US" sz="540" b="1" spc="30" kern="0" dirty="0">
+                <a:solidFill>
+                  <a:srgbClr val="2F8B72"/>
+                </a:solidFill>
+                <a:latin typeface="Aptos" pitchFamily="34" charset="0"/>
+                <a:ea typeface="Aptos" pitchFamily="34" charset="-122"/>
+                <a:cs typeface="Aptos" pitchFamily="34" charset="-120"/>
+              </a:rPr>
+              <a:t>03</a:t>
+            </a:r>
+            <a:endParaRPr lang="en-US" sz="540" dirty="0"/>
+          </a:p>
+        </p:txBody>
+      </p:sp>
+      <p:sp>
+        <p:nvSpPr>
+          <p:cNvPr id="22" name="Text 20"/>
+          <p:cNvSpPr txBox="1"/>
+          <p:nvPr/>
+        </p:nvSpPr>
+        <p:spPr>
+          <a:xfrm>
+            <a:off x="4541520" y="2674620"/>
+            <a:ext cx="1356360" cy="175260"/>
+          </a:xfrm>
+          <a:prstGeom prst="rect">
+            <a:avLst/>
+          </a:prstGeom>
+          <a:noFill/>
+          <a:ln/>
+        </p:spPr>
+        <p:txBody>
+          <a:bodyPr wrap="square" lIns="0" tIns="0" rIns="0" bIns="0" rtlCol="0" anchor="ctr">
+            <a:normAutofit/>
+          </a:bodyPr>
+          <a:lstStyle/>
+          <a:p>
+            <a:pPr algn="l" indent="0" marL="0">
+              <a:buNone/>
+            </a:pPr>
+            <a:r>
+              <a:rPr lang="en-US" sz="780" b="1" spc="80" kern="0" dirty="0">
+                <a:solidFill>
+                  <a:srgbClr val="2F8B72"/>
+                </a:solidFill>
+                <a:latin typeface="Aptos" pitchFamily="34" charset="0"/>
+                <a:ea typeface="Aptos" pitchFamily="34" charset="-122"/>
+                <a:cs typeface="Aptos" pitchFamily="34" charset="-120"/>
+              </a:rPr>
+              <a:t>PROMISING</a:t>
+            </a:r>
+            <a:endParaRPr lang="en-US" sz="780" dirty="0"/>
+          </a:p>
+        </p:txBody>
+      </p:sp>
+      <p:sp>
+        <p:nvSpPr>
+          <p:cNvPr id="23" name="Text 21"/>
+          <p:cNvSpPr txBox="1"/>
+          <p:nvPr/>
+        </p:nvSpPr>
+        <p:spPr>
+          <a:xfrm>
+            <a:off x="4541520" y="2895600"/>
+            <a:ext cx="1356360" cy="167640"/>
+          </a:xfrm>
+          <a:prstGeom prst="rect">
+            <a:avLst/>
+          </a:prstGeom>
+          <a:noFill/>
+          <a:ln/>
+        </p:spPr>
+        <p:txBody>
+          <a:bodyPr wrap="square" lIns="0" tIns="0" rIns="0" bIns="0" rtlCol="0" anchor="ctr">
+            <a:normAutofit/>
+          </a:bodyPr>
+          <a:lstStyle/>
+          <a:p>
+            <a:pPr algn="l" indent="0" marL="0">
+              <a:buNone/>
+            </a:pPr>
+            <a:r>
+              <a:rPr lang="en-US" sz="660" b="1" dirty="0">
+                <a:solidFill>
+                  <a:srgbClr val="344258"/>
+                </a:solidFill>
+                <a:latin typeface="Aptos" pitchFamily="34" charset="0"/>
+                <a:ea typeface="Aptos" pitchFamily="34" charset="-122"/>
+                <a:cs typeface="Aptos" pitchFamily="34" charset="-120"/>
+              </a:rPr>
+              <a:t>Human gate</a:t>
+            </a:r>
+            <a:endParaRPr lang="en-US" sz="660" dirty="0"/>
+          </a:p>
+        </p:txBody>
+      </p:sp>
+      <p:sp>
+        <p:nvSpPr>
+          <p:cNvPr id="24" name="Shape 22"/>
+          <p:cNvSpPr/>
+          <p:nvPr/>
+        </p:nvSpPr>
+        <p:spPr>
+          <a:xfrm>
+            <a:off x="6042660" y="2727960"/>
+            <a:ext cx="213360" cy="0"/>
+          </a:xfrm>
+          <a:prstGeom prst="line">
+            <a:avLst/>
+          </a:prstGeom>
+          <a:noFill/>
+          <a:ln w="22860">
+            <a:solidFill>
+              <a:srgbClr val="2F8B72"/>
+            </a:solidFill>
+            <a:prstDash val="solid"/>
+            <a:headEnd type="none"/>
+            <a:tailEnd type="triangle"/>
+          </a:ln>
+        </p:spPr>
+      </p:sp>
+      <p:sp>
+        <p:nvSpPr>
+          <p:cNvPr id="25" name="Shape 23"/>
+          <p:cNvSpPr/>
+          <p:nvPr/>
+        </p:nvSpPr>
+        <p:spPr>
+          <a:xfrm>
+            <a:off x="6286500" y="2286000"/>
+            <a:ext cx="1600200" cy="883920"/>
+          </a:xfrm>
+          <a:prstGeom prst="roundRect">
+            <a:avLst>
+              <a:gd name="adj" fmla="val 14483"/>
             </a:avLst>
           </a:prstGeom>
           <a:solidFill>
@@ -11579,372 +11978,18 @@
       </p:sp>
       <p:sp>
         <p:nvSpPr>
-          <p:cNvPr id="14" name="Text 12"/>
-          <p:cNvSpPr txBox="1"/>
-          <p:nvPr/>
-        </p:nvSpPr>
-        <p:spPr>
-          <a:xfrm>
-            <a:off x="876300" y="3581400"/>
-            <a:ext cx="1943100" cy="205740"/>
-          </a:xfrm>
-          <a:prstGeom prst="rect">
-            <a:avLst/>
-          </a:prstGeom>
-          <a:noFill/>
-          <a:ln/>
-        </p:spPr>
-        <p:txBody>
-          <a:bodyPr wrap="square" lIns="0" tIns="0" rIns="0" bIns="0" rtlCol="0" anchor="ctr">
-            <a:normAutofit/>
-          </a:bodyPr>
-          <a:lstStyle/>
-          <a:p>
-            <a:pPr algn="l" indent="0" marL="0">
-              <a:buNone/>
-            </a:pPr>
-            <a:r>
-              <a:rPr lang="en-US" sz="960" b="1" dirty="0">
-                <a:solidFill>
-                  <a:srgbClr val="B87932"/>
-                </a:solidFill>
-                <a:latin typeface="Aptos" pitchFamily="34" charset="0"/>
-                <a:ea typeface="Aptos" pitchFamily="34" charset="-122"/>
-                <a:cs typeface="Aptos" pitchFamily="34" charset="-120"/>
-              </a:rPr>
-              <a:t>ARQ + Redis</a:t>
-            </a:r>
-            <a:endParaRPr lang="en-US" sz="960" dirty="0"/>
-          </a:p>
-        </p:txBody>
-      </p:sp>
-      <p:sp>
-        <p:nvSpPr>
-          <p:cNvPr id="15" name="Text 13"/>
-          <p:cNvSpPr txBox="1"/>
-          <p:nvPr/>
-        </p:nvSpPr>
-        <p:spPr>
-          <a:xfrm>
-            <a:off x="2819400" y="3596640"/>
-            <a:ext cx="1219200" cy="182880"/>
-          </a:xfrm>
-          <a:prstGeom prst="rect">
-            <a:avLst/>
-          </a:prstGeom>
-          <a:noFill/>
-          <a:ln/>
-        </p:spPr>
-        <p:txBody>
-          <a:bodyPr wrap="square" lIns="0" tIns="0" rIns="0" bIns="0" rtlCol="0" anchor="ctr">
-            <a:normAutofit/>
-          </a:bodyPr>
-          <a:lstStyle/>
-          <a:p>
-            <a:pPr algn="r" indent="0" marL="0">
-              <a:buNone/>
-            </a:pPr>
-            <a:r>
-              <a:rPr lang="en-US" sz="720" b="1" dirty="0">
-                <a:solidFill>
-                  <a:srgbClr val="718097"/>
-                </a:solidFill>
-                <a:latin typeface="Aptos" pitchFamily="34" charset="0"/>
-                <a:ea typeface="Aptos" pitchFamily="34" charset="-122"/>
-                <a:cs typeface="Aptos" pitchFamily="34" charset="-120"/>
-              </a:rPr>
-              <a:t>Async jobs</a:t>
-            </a:r>
-            <a:endParaRPr lang="en-US" sz="720" dirty="0"/>
-          </a:p>
-        </p:txBody>
-      </p:sp>
-      <p:sp>
-        <p:nvSpPr>
-          <p:cNvPr id="16" name="Shape 14"/>
-          <p:cNvSpPr/>
-          <p:nvPr/>
-        </p:nvSpPr>
-        <p:spPr>
-          <a:xfrm>
-            <a:off x="2476500" y="4038600"/>
-            <a:ext cx="0" cy="175260"/>
-          </a:xfrm>
-          <a:prstGeom prst="line">
-            <a:avLst/>
-          </a:prstGeom>
-          <a:noFill/>
-          <a:ln w="25400">
-            <a:solidFill>
-              <a:srgbClr val="DCE5F0"/>
-            </a:solidFill>
-            <a:prstDash val="solid"/>
-            <a:headEnd type="none"/>
-            <a:tailEnd type="none"/>
-          </a:ln>
-        </p:spPr>
-      </p:sp>
-      <p:sp>
-        <p:nvSpPr>
-          <p:cNvPr id="17" name="Shape 15"/>
-          <p:cNvSpPr/>
-          <p:nvPr/>
-        </p:nvSpPr>
-        <p:spPr>
-          <a:xfrm>
-            <a:off x="685800" y="4213860"/>
-            <a:ext cx="3581400" cy="518160"/>
+          <p:cNvPr id="26" name="Shape 24"/>
+          <p:cNvSpPr/>
+          <p:nvPr/>
+        </p:nvSpPr>
+        <p:spPr>
+          <a:xfrm>
+            <a:off x="6408420" y="2400300"/>
+            <a:ext cx="320040" cy="213360"/>
           </a:xfrm>
           <a:prstGeom prst="roundRect">
             <a:avLst>
-              <a:gd name="adj" fmla="val 21176"/>
-            </a:avLst>
-          </a:prstGeom>
-          <a:solidFill>
-            <a:srgbClr val="E4F2ED"/>
-          </a:solidFill>
-          <a:ln w="6350">
-            <a:solidFill>
-              <a:srgbClr val="E4F2ED">
-                <a:alpha val="0"/>
-              </a:srgbClr>
-            </a:solidFill>
-            <a:prstDash val="solid"/>
-          </a:ln>
-        </p:spPr>
-      </p:sp>
-      <p:sp>
-        <p:nvSpPr>
-          <p:cNvPr id="18" name="Text 16"/>
-          <p:cNvSpPr txBox="1"/>
-          <p:nvPr/>
-        </p:nvSpPr>
-        <p:spPr>
-          <a:xfrm>
-            <a:off x="876300" y="4274820"/>
-            <a:ext cx="1943100" cy="205740"/>
-          </a:xfrm>
-          <a:prstGeom prst="rect">
-            <a:avLst/>
-          </a:prstGeom>
-          <a:noFill/>
-          <a:ln/>
-        </p:spPr>
-        <p:txBody>
-          <a:bodyPr wrap="square" lIns="0" tIns="0" rIns="0" bIns="0" rtlCol="0" anchor="ctr">
-            <a:normAutofit/>
-          </a:bodyPr>
-          <a:lstStyle/>
-          <a:p>
-            <a:pPr algn="l" indent="0" marL="0">
-              <a:buNone/>
-            </a:pPr>
-            <a:r>
-              <a:rPr lang="en-US" sz="960" b="1" dirty="0">
-                <a:solidFill>
-                  <a:srgbClr val="2F8B72"/>
-                </a:solidFill>
-                <a:latin typeface="Aptos" pitchFamily="34" charset="0"/>
-                <a:ea typeface="Aptos" pitchFamily="34" charset="-122"/>
-                <a:cs typeface="Aptos" pitchFamily="34" charset="-120"/>
-              </a:rPr>
-              <a:t>Postgres + pgvector</a:t>
-            </a:r>
-            <a:endParaRPr lang="en-US" sz="960" dirty="0"/>
-          </a:p>
-        </p:txBody>
-      </p:sp>
-      <p:sp>
-        <p:nvSpPr>
-          <p:cNvPr id="19" name="Text 17"/>
-          <p:cNvSpPr txBox="1"/>
-          <p:nvPr/>
-        </p:nvSpPr>
-        <p:spPr>
-          <a:xfrm>
-            <a:off x="2819400" y="4290060"/>
-            <a:ext cx="1219200" cy="182880"/>
-          </a:xfrm>
-          <a:prstGeom prst="rect">
-            <a:avLst/>
-          </a:prstGeom>
-          <a:noFill/>
-          <a:ln/>
-        </p:spPr>
-        <p:txBody>
-          <a:bodyPr wrap="square" lIns="0" tIns="0" rIns="0" bIns="0" rtlCol="0" anchor="ctr">
-            <a:normAutofit/>
-          </a:bodyPr>
-          <a:lstStyle/>
-          <a:p>
-            <a:pPr algn="r" indent="0" marL="0">
-              <a:buNone/>
-            </a:pPr>
-            <a:r>
-              <a:rPr lang="en-US" sz="720" b="1" dirty="0">
-                <a:solidFill>
-                  <a:srgbClr val="718097"/>
-                </a:solidFill>
-                <a:latin typeface="Aptos" pitchFamily="34" charset="0"/>
-                <a:ea typeface="Aptos" pitchFamily="34" charset="-122"/>
-                <a:cs typeface="Aptos" pitchFamily="34" charset="-120"/>
-              </a:rPr>
-              <a:t>Memory + graph</a:t>
-            </a:r>
-            <a:endParaRPr lang="en-US" sz="720" dirty="0"/>
-          </a:p>
-        </p:txBody>
-      </p:sp>
-      <p:sp>
-        <p:nvSpPr>
-          <p:cNvPr id="20" name="Shape 18"/>
-          <p:cNvSpPr/>
-          <p:nvPr/>
-        </p:nvSpPr>
-        <p:spPr>
-          <a:xfrm>
-            <a:off x="2476500" y="4732020"/>
-            <a:ext cx="0" cy="175260"/>
-          </a:xfrm>
-          <a:prstGeom prst="line">
-            <a:avLst/>
-          </a:prstGeom>
-          <a:noFill/>
-          <a:ln w="25400">
-            <a:solidFill>
-              <a:srgbClr val="DCE5F0"/>
-            </a:solidFill>
-            <a:prstDash val="solid"/>
-            <a:headEnd type="none"/>
-            <a:tailEnd type="none"/>
-          </a:ln>
-        </p:spPr>
-      </p:sp>
-      <p:sp>
-        <p:nvSpPr>
-          <p:cNvPr id="21" name="Shape 19"/>
-          <p:cNvSpPr/>
-          <p:nvPr/>
-        </p:nvSpPr>
-        <p:spPr>
-          <a:xfrm>
-            <a:off x="685800" y="4907280"/>
-            <a:ext cx="3581400" cy="518160"/>
-          </a:xfrm>
-          <a:prstGeom prst="roundRect">
-            <a:avLst>
-              <a:gd name="adj" fmla="val 21176"/>
-            </a:avLst>
-          </a:prstGeom>
-          <a:solidFill>
-            <a:srgbClr val="EAF0F6"/>
-          </a:solidFill>
-          <a:ln w="6350">
-            <a:solidFill>
-              <a:srgbClr val="EAF0F6">
-                <a:alpha val="0"/>
-              </a:srgbClr>
-            </a:solidFill>
-            <a:prstDash val="solid"/>
-          </a:ln>
-        </p:spPr>
-      </p:sp>
-      <p:sp>
-        <p:nvSpPr>
-          <p:cNvPr id="22" name="Text 20"/>
-          <p:cNvSpPr txBox="1"/>
-          <p:nvPr/>
-        </p:nvSpPr>
-        <p:spPr>
-          <a:xfrm>
-            <a:off x="876300" y="4968240"/>
-            <a:ext cx="1943100" cy="205740"/>
-          </a:xfrm>
-          <a:prstGeom prst="rect">
-            <a:avLst/>
-          </a:prstGeom>
-          <a:noFill/>
-          <a:ln/>
-        </p:spPr>
-        <p:txBody>
-          <a:bodyPr wrap="square" lIns="0" tIns="0" rIns="0" bIns="0" rtlCol="0" anchor="ctr">
-            <a:normAutofit/>
-          </a:bodyPr>
-          <a:lstStyle/>
-          <a:p>
-            <a:pPr algn="l" indent="0" marL="0">
-              <a:buNone/>
-            </a:pPr>
-            <a:r>
-              <a:rPr lang="en-US" sz="960" b="1" dirty="0">
-                <a:solidFill>
-                  <a:srgbClr val="344258"/>
-                </a:solidFill>
-                <a:latin typeface="Aptos" pitchFamily="34" charset="0"/>
-                <a:ea typeface="Aptos" pitchFamily="34" charset="-122"/>
-                <a:cs typeface="Aptos" pitchFamily="34" charset="-120"/>
-              </a:rPr>
-              <a:t>MinIO + Docker</a:t>
-            </a:r>
-            <a:endParaRPr lang="en-US" sz="960" dirty="0"/>
-          </a:p>
-        </p:txBody>
-      </p:sp>
-      <p:sp>
-        <p:nvSpPr>
-          <p:cNvPr id="23" name="Text 21"/>
-          <p:cNvSpPr txBox="1"/>
-          <p:nvPr/>
-        </p:nvSpPr>
-        <p:spPr>
-          <a:xfrm>
-            <a:off x="2819400" y="4983480"/>
-            <a:ext cx="1219200" cy="182880"/>
-          </a:xfrm>
-          <a:prstGeom prst="rect">
-            <a:avLst/>
-          </a:prstGeom>
-          <a:noFill/>
-          <a:ln/>
-        </p:spPr>
-        <p:txBody>
-          <a:bodyPr wrap="square" lIns="0" tIns="0" rIns="0" bIns="0" rtlCol="0" anchor="ctr">
-            <a:normAutofit/>
-          </a:bodyPr>
-          <a:lstStyle/>
-          <a:p>
-            <a:pPr algn="r" indent="0" marL="0">
-              <a:buNone/>
-            </a:pPr>
-            <a:r>
-              <a:rPr lang="en-US" sz="720" b="1" dirty="0">
-                <a:solidFill>
-                  <a:srgbClr val="718097"/>
-                </a:solidFill>
-                <a:latin typeface="Aptos" pitchFamily="34" charset="0"/>
-                <a:ea typeface="Aptos" pitchFamily="34" charset="-122"/>
-                <a:cs typeface="Aptos" pitchFamily="34" charset="-120"/>
-              </a:rPr>
-              <a:t>Artifacts + deployment</a:t>
-            </a:r>
-            <a:endParaRPr lang="en-US" sz="720" dirty="0"/>
-          </a:p>
-        </p:txBody>
-      </p:sp>
-      <p:sp>
-        <p:nvSpPr>
-          <p:cNvPr id="24" name="Shape 22"/>
-          <p:cNvSpPr/>
-          <p:nvPr/>
-        </p:nvSpPr>
-        <p:spPr>
-          <a:xfrm>
-            <a:off x="4762500" y="1866900"/>
-            <a:ext cx="6743700" cy="4076700"/>
-          </a:xfrm>
-          <a:prstGeom prst="roundRect">
-            <a:avLst>
-              <a:gd name="adj" fmla="val 4037"/>
+              <a:gd name="adj" fmla="val 68571"/>
             </a:avLst>
           </a:prstGeom>
           <a:solidFill>
@@ -11953,6 +11998,389 @@
           <a:ln w="6350">
             <a:solidFill>
               <a:srgbClr val="FFFFFF">
+                <a:alpha val="0"/>
+              </a:srgbClr>
+            </a:solidFill>
+            <a:prstDash val="solid"/>
+          </a:ln>
+        </p:spPr>
+      </p:sp>
+      <p:sp>
+        <p:nvSpPr>
+          <p:cNvPr id="27" name="Text 25"/>
+          <p:cNvSpPr txBox="1"/>
+          <p:nvPr/>
+        </p:nvSpPr>
+        <p:spPr>
+          <a:xfrm>
+            <a:off x="6484620" y="2423160"/>
+            <a:ext cx="167640" cy="167640"/>
+          </a:xfrm>
+          <a:prstGeom prst="rect">
+            <a:avLst/>
+          </a:prstGeom>
+          <a:noFill/>
+          <a:ln/>
+        </p:spPr>
+        <p:txBody>
+          <a:bodyPr wrap="square" lIns="0" tIns="0" rIns="0" bIns="0" rtlCol="0" anchor="ctr">
+            <a:normAutofit/>
+          </a:bodyPr>
+          <a:lstStyle/>
+          <a:p>
+            <a:pPr algn="ctr" indent="0" marL="0">
+              <a:buNone/>
+            </a:pPr>
+            <a:r>
+              <a:rPr lang="en-US" sz="540" b="1" spc="30" kern="0" dirty="0">
+                <a:solidFill>
+                  <a:srgbClr val="B87932"/>
+                </a:solidFill>
+                <a:latin typeface="Aptos" pitchFamily="34" charset="0"/>
+                <a:ea typeface="Aptos" pitchFamily="34" charset="-122"/>
+                <a:cs typeface="Aptos" pitchFamily="34" charset="-120"/>
+              </a:rPr>
+              <a:t>04</a:t>
+            </a:r>
+            <a:endParaRPr lang="en-US" sz="540" dirty="0"/>
+          </a:p>
+        </p:txBody>
+      </p:sp>
+      <p:sp>
+        <p:nvSpPr>
+          <p:cNvPr id="28" name="Text 26"/>
+          <p:cNvSpPr txBox="1"/>
+          <p:nvPr/>
+        </p:nvSpPr>
+        <p:spPr>
+          <a:xfrm>
+            <a:off x="6408420" y="2674620"/>
+            <a:ext cx="1356360" cy="175260"/>
+          </a:xfrm>
+          <a:prstGeom prst="rect">
+            <a:avLst/>
+          </a:prstGeom>
+          <a:noFill/>
+          <a:ln/>
+        </p:spPr>
+        <p:txBody>
+          <a:bodyPr wrap="square" lIns="0" tIns="0" rIns="0" bIns="0" rtlCol="0" anchor="ctr">
+            <a:normAutofit/>
+          </a:bodyPr>
+          <a:lstStyle/>
+          <a:p>
+            <a:pPr algn="l" indent="0" marL="0">
+              <a:buNone/>
+            </a:pPr>
+            <a:r>
+              <a:rPr lang="en-US" sz="780" b="1" spc="80" kern="0" dirty="0">
+                <a:solidFill>
+                  <a:srgbClr val="B87932"/>
+                </a:solidFill>
+                <a:latin typeface="Aptos" pitchFamily="34" charset="0"/>
+                <a:ea typeface="Aptos" pitchFamily="34" charset="-122"/>
+                <a:cs typeface="Aptos" pitchFamily="34" charset="-120"/>
+              </a:rPr>
+              <a:t>FOOTPRINTS</a:t>
+            </a:r>
+            <a:endParaRPr lang="en-US" sz="780" dirty="0"/>
+          </a:p>
+        </p:txBody>
+      </p:sp>
+      <p:sp>
+        <p:nvSpPr>
+          <p:cNvPr id="29" name="Text 27"/>
+          <p:cNvSpPr txBox="1"/>
+          <p:nvPr/>
+        </p:nvSpPr>
+        <p:spPr>
+          <a:xfrm>
+            <a:off x="6408420" y="2895600"/>
+            <a:ext cx="1356360" cy="167640"/>
+          </a:xfrm>
+          <a:prstGeom prst="rect">
+            <a:avLst/>
+          </a:prstGeom>
+          <a:noFill/>
+          <a:ln/>
+        </p:spPr>
+        <p:txBody>
+          <a:bodyPr wrap="square" lIns="0" tIns="0" rIns="0" bIns="0" rtlCol="0" anchor="ctr">
+            <a:normAutofit/>
+          </a:bodyPr>
+          <a:lstStyle/>
+          <a:p>
+            <a:pPr algn="l" indent="0" marL="0">
+              <a:buNone/>
+            </a:pPr>
+            <a:r>
+              <a:rPr lang="en-US" sz="660" b="1" dirty="0">
+                <a:solidFill>
+                  <a:srgbClr val="344258"/>
+                </a:solidFill>
+                <a:latin typeface="Aptos" pitchFamily="34" charset="0"/>
+                <a:ea typeface="Aptos" pitchFamily="34" charset="-122"/>
+                <a:cs typeface="Aptos" pitchFamily="34" charset="-120"/>
+              </a:rPr>
+              <a:t>Identity + evidence</a:t>
+            </a:r>
+            <a:endParaRPr lang="en-US" sz="660" dirty="0"/>
+          </a:p>
+        </p:txBody>
+      </p:sp>
+      <p:sp>
+        <p:nvSpPr>
+          <p:cNvPr id="30" name="Shape 28"/>
+          <p:cNvSpPr/>
+          <p:nvPr/>
+        </p:nvSpPr>
+        <p:spPr>
+          <a:xfrm>
+            <a:off x="7909560" y="2727960"/>
+            <a:ext cx="213360" cy="0"/>
+          </a:xfrm>
+          <a:prstGeom prst="line">
+            <a:avLst/>
+          </a:prstGeom>
+          <a:noFill/>
+          <a:ln w="22860">
+            <a:solidFill>
+              <a:srgbClr val="B87932"/>
+            </a:solidFill>
+            <a:prstDash val="solid"/>
+            <a:headEnd type="none"/>
+            <a:tailEnd type="triangle"/>
+          </a:ln>
+        </p:spPr>
+      </p:sp>
+      <p:sp>
+        <p:nvSpPr>
+          <p:cNvPr id="31" name="Shape 29"/>
+          <p:cNvSpPr/>
+          <p:nvPr/>
+        </p:nvSpPr>
+        <p:spPr>
+          <a:xfrm>
+            <a:off x="8153400" y="2286000"/>
+            <a:ext cx="1600200" cy="883920"/>
+          </a:xfrm>
+          <a:prstGeom prst="roundRect">
+            <a:avLst>
+              <a:gd name="adj" fmla="val 14483"/>
+            </a:avLst>
+          </a:prstGeom>
+          <a:solidFill>
+            <a:srgbClr val="EEE8F8"/>
+          </a:solidFill>
+          <a:ln w="6350">
+            <a:solidFill>
+              <a:srgbClr val="EEE8F8">
+                <a:alpha val="0"/>
+              </a:srgbClr>
+            </a:solidFill>
+            <a:prstDash val="solid"/>
+          </a:ln>
+        </p:spPr>
+      </p:sp>
+      <p:sp>
+        <p:nvSpPr>
+          <p:cNvPr id="32" name="Shape 30"/>
+          <p:cNvSpPr/>
+          <p:nvPr/>
+        </p:nvSpPr>
+        <p:spPr>
+          <a:xfrm>
+            <a:off x="8275320" y="2400300"/>
+            <a:ext cx="320040" cy="213360"/>
+          </a:xfrm>
+          <a:prstGeom prst="roundRect">
+            <a:avLst>
+              <a:gd name="adj" fmla="val 68571"/>
+            </a:avLst>
+          </a:prstGeom>
+          <a:solidFill>
+            <a:srgbClr val="FFFFFF"/>
+          </a:solidFill>
+          <a:ln w="6350">
+            <a:solidFill>
+              <a:srgbClr val="FFFFFF">
+                <a:alpha val="0"/>
+              </a:srgbClr>
+            </a:solidFill>
+            <a:prstDash val="solid"/>
+          </a:ln>
+        </p:spPr>
+      </p:sp>
+      <p:sp>
+        <p:nvSpPr>
+          <p:cNvPr id="33" name="Text 31"/>
+          <p:cNvSpPr txBox="1"/>
+          <p:nvPr/>
+        </p:nvSpPr>
+        <p:spPr>
+          <a:xfrm>
+            <a:off x="8351520" y="2423160"/>
+            <a:ext cx="167640" cy="167640"/>
+          </a:xfrm>
+          <a:prstGeom prst="rect">
+            <a:avLst/>
+          </a:prstGeom>
+          <a:noFill/>
+          <a:ln/>
+        </p:spPr>
+        <p:txBody>
+          <a:bodyPr wrap="square" lIns="0" tIns="0" rIns="0" bIns="0" rtlCol="0" anchor="ctr">
+            <a:normAutofit/>
+          </a:bodyPr>
+          <a:lstStyle/>
+          <a:p>
+            <a:pPr algn="ctr" indent="0" marL="0">
+              <a:buNone/>
+            </a:pPr>
+            <a:r>
+              <a:rPr lang="en-US" sz="540" b="1" spc="30" kern="0" dirty="0">
+                <a:solidFill>
+                  <a:srgbClr val="7656A5"/>
+                </a:solidFill>
+                <a:latin typeface="Aptos" pitchFamily="34" charset="0"/>
+                <a:ea typeface="Aptos" pitchFamily="34" charset="-122"/>
+                <a:cs typeface="Aptos" pitchFamily="34" charset="-120"/>
+              </a:rPr>
+              <a:t>05</a:t>
+            </a:r>
+            <a:endParaRPr lang="en-US" sz="540" dirty="0"/>
+          </a:p>
+        </p:txBody>
+      </p:sp>
+      <p:sp>
+        <p:nvSpPr>
+          <p:cNvPr id="34" name="Text 32"/>
+          <p:cNvSpPr txBox="1"/>
+          <p:nvPr/>
+        </p:nvSpPr>
+        <p:spPr>
+          <a:xfrm>
+            <a:off x="8275320" y="2674620"/>
+            <a:ext cx="1356360" cy="175260"/>
+          </a:xfrm>
+          <a:prstGeom prst="rect">
+            <a:avLst/>
+          </a:prstGeom>
+          <a:noFill/>
+          <a:ln/>
+        </p:spPr>
+        <p:txBody>
+          <a:bodyPr wrap="square" lIns="0" tIns="0" rIns="0" bIns="0" rtlCol="0" anchor="ctr">
+            <a:normAutofit/>
+          </a:bodyPr>
+          <a:lstStyle/>
+          <a:p>
+            <a:pPr algn="l" indent="0" marL="0">
+              <a:buNone/>
+            </a:pPr>
+            <a:r>
+              <a:rPr lang="en-US" sz="780" b="1" spc="80" kern="0" dirty="0">
+                <a:solidFill>
+                  <a:srgbClr val="7656A5"/>
+                </a:solidFill>
+                <a:latin typeface="Aptos" pitchFamily="34" charset="0"/>
+                <a:ea typeface="Aptos" pitchFamily="34" charset="-122"/>
+                <a:cs typeface="Aptos" pitchFamily="34" charset="-120"/>
+              </a:rPr>
+              <a:t>3-AXIS SCORE</a:t>
+            </a:r>
+            <a:endParaRPr lang="en-US" sz="780" dirty="0"/>
+          </a:p>
+        </p:txBody>
+      </p:sp>
+      <p:sp>
+        <p:nvSpPr>
+          <p:cNvPr id="35" name="Text 33"/>
+          <p:cNvSpPr txBox="1"/>
+          <p:nvPr/>
+        </p:nvSpPr>
+        <p:spPr>
+          <a:xfrm>
+            <a:off x="8275320" y="2895600"/>
+            <a:ext cx="1356360" cy="167640"/>
+          </a:xfrm>
+          <a:prstGeom prst="rect">
+            <a:avLst/>
+          </a:prstGeom>
+          <a:noFill/>
+          <a:ln/>
+        </p:spPr>
+        <p:txBody>
+          <a:bodyPr wrap="square" lIns="0" tIns="0" rIns="0" bIns="0" rtlCol="0" anchor="ctr">
+            <a:normAutofit/>
+          </a:bodyPr>
+          <a:lstStyle/>
+          <a:p>
+            <a:pPr algn="l" indent="0" marL="0">
+              <a:buNone/>
+            </a:pPr>
+            <a:r>
+              <a:rPr lang="en-US" sz="660" b="1" dirty="0">
+                <a:solidFill>
+                  <a:srgbClr val="344258"/>
+                </a:solidFill>
+                <a:latin typeface="Aptos" pitchFamily="34" charset="0"/>
+                <a:ea typeface="Aptos" pitchFamily="34" charset="-122"/>
+                <a:cs typeface="Aptos" pitchFamily="34" charset="-120"/>
+              </a:rPr>
+              <a:t>Founder · Market · Fit</a:t>
+            </a:r>
+            <a:endParaRPr lang="en-US" sz="660" dirty="0"/>
+          </a:p>
+        </p:txBody>
+      </p:sp>
+      <p:sp>
+        <p:nvSpPr>
+          <p:cNvPr id="36" name="Shape 34"/>
+          <p:cNvSpPr/>
+          <p:nvPr/>
+        </p:nvSpPr>
+        <p:spPr>
+          <a:xfrm>
+            <a:off x="9776460" y="2727960"/>
+            <a:ext cx="213360" cy="0"/>
+          </a:xfrm>
+          <a:prstGeom prst="line">
+            <a:avLst/>
+          </a:prstGeom>
+          <a:noFill/>
+          <a:ln w="22860">
+            <a:solidFill>
+              <a:srgbClr val="7656A5"/>
+            </a:solidFill>
+            <a:prstDash val="solid"/>
+            <a:headEnd type="none"/>
+            <a:tailEnd type="triangle"/>
+          </a:ln>
+        </p:spPr>
+      </p:sp>
+      <p:sp>
+        <p:nvSpPr>
+          <p:cNvPr id="37" name="Shape 35"/>
+          <p:cNvSpPr/>
+          <p:nvPr/>
+        </p:nvSpPr>
+        <p:spPr>
+          <a:xfrm>
+            <a:off x="10020300" y="2286000"/>
+            <a:ext cx="1600200" cy="883920"/>
+          </a:xfrm>
+          <a:prstGeom prst="roundRect">
+            <a:avLst>
+              <a:gd name="adj" fmla="val 14483"/>
+            </a:avLst>
+          </a:prstGeom>
+          <a:solidFill>
+            <a:srgbClr val="E7EEF9"/>
+          </a:solidFill>
+          <a:ln w="6350">
+            <a:solidFill>
+              <a:srgbClr val="E7EEF9">
                 <a:alpha val="0"/>
               </a:srgbClr>
             </a:solidFill>
@@ -11969,59 +12397,684 @@
       </p:sp>
       <p:sp>
         <p:nvSpPr>
-          <p:cNvPr id="25" name="Text 23"/>
-          <p:cNvSpPr txBox="1"/>
-          <p:nvPr/>
-        </p:nvSpPr>
-        <p:spPr>
-          <a:xfrm>
-            <a:off x="5067300" y="2057400"/>
-            <a:ext cx="1981200" cy="213360"/>
-          </a:xfrm>
-          <a:prstGeom prst="rect">
-            <a:avLst/>
-          </a:prstGeom>
-          <a:noFill/>
-          <a:ln/>
-        </p:spPr>
-        <p:txBody>
-          <a:bodyPr wrap="square" lIns="0" tIns="0" rIns="0" bIns="0" rtlCol="0" anchor="ctr">
-            <a:normAutofit/>
-          </a:bodyPr>
-          <a:lstStyle/>
-          <a:p>
-            <a:pPr algn="l" indent="0" marL="0">
-              <a:buNone/>
-            </a:pPr>
-            <a:r>
-              <a:rPr lang="en-US" sz="720" b="1" spc="180" kern="0" dirty="0">
-                <a:solidFill>
-                  <a:srgbClr val="557DC0"/>
-                </a:solidFill>
-                <a:latin typeface="Aptos" pitchFamily="34" charset="0"/>
-                <a:ea typeface="Aptos" pitchFamily="34" charset="-122"/>
-                <a:cs typeface="Aptos" pitchFamily="34" charset="-120"/>
-              </a:rPr>
-              <a:t>SYSTEM FLOW</a:t>
-            </a:r>
-            <a:endParaRPr lang="en-US" sz="720" dirty="0"/>
-          </a:p>
-        </p:txBody>
-      </p:sp>
-      <p:sp>
-        <p:nvSpPr>
-          <p:cNvPr id="26" name="Shape 24"/>
-          <p:cNvSpPr/>
-          <p:nvPr/>
-        </p:nvSpPr>
-        <p:spPr>
-          <a:xfrm>
-            <a:off x="5067300" y="2400300"/>
-            <a:ext cx="6134100" cy="441960"/>
+          <p:cNvPr id="38" name="Shape 36"/>
+          <p:cNvSpPr/>
+          <p:nvPr/>
+        </p:nvSpPr>
+        <p:spPr>
+          <a:xfrm>
+            <a:off x="10142220" y="2400300"/>
+            <a:ext cx="320040" cy="213360"/>
           </a:xfrm>
           <a:prstGeom prst="roundRect">
             <a:avLst>
-              <a:gd name="adj" fmla="val 24828"/>
+              <a:gd name="adj" fmla="val 68571"/>
+            </a:avLst>
+          </a:prstGeom>
+          <a:solidFill>
+            <a:srgbClr val="FFFFFF"/>
+          </a:solidFill>
+          <a:ln w="6350">
+            <a:solidFill>
+              <a:srgbClr val="FFFFFF">
+                <a:alpha val="0"/>
+              </a:srgbClr>
+            </a:solidFill>
+            <a:prstDash val="solid"/>
+          </a:ln>
+        </p:spPr>
+      </p:sp>
+      <p:sp>
+        <p:nvSpPr>
+          <p:cNvPr id="39" name="Text 37"/>
+          <p:cNvSpPr txBox="1"/>
+          <p:nvPr/>
+        </p:nvSpPr>
+        <p:spPr>
+          <a:xfrm>
+            <a:off x="10218420" y="2423160"/>
+            <a:ext cx="167640" cy="167640"/>
+          </a:xfrm>
+          <a:prstGeom prst="rect">
+            <a:avLst/>
+          </a:prstGeom>
+          <a:noFill/>
+          <a:ln/>
+        </p:spPr>
+        <p:txBody>
+          <a:bodyPr wrap="square" lIns="0" tIns="0" rIns="0" bIns="0" rtlCol="0" anchor="ctr">
+            <a:normAutofit/>
+          </a:bodyPr>
+          <a:lstStyle/>
+          <a:p>
+            <a:pPr algn="ctr" indent="0" marL="0">
+              <a:buNone/>
+            </a:pPr>
+            <a:r>
+              <a:rPr lang="en-US" sz="540" b="1" spc="30" kern="0" dirty="0">
+                <a:solidFill>
+                  <a:srgbClr val="557DC0"/>
+                </a:solidFill>
+                <a:latin typeface="Aptos" pitchFamily="34" charset="0"/>
+                <a:ea typeface="Aptos" pitchFamily="34" charset="-122"/>
+                <a:cs typeface="Aptos" pitchFamily="34" charset="-120"/>
+              </a:rPr>
+              <a:t>06</a:t>
+            </a:r>
+            <a:endParaRPr lang="en-US" sz="540" dirty="0"/>
+          </a:p>
+        </p:txBody>
+      </p:sp>
+      <p:sp>
+        <p:nvSpPr>
+          <p:cNvPr id="40" name="Text 38"/>
+          <p:cNvSpPr txBox="1"/>
+          <p:nvPr/>
+        </p:nvSpPr>
+        <p:spPr>
+          <a:xfrm>
+            <a:off x="10142220" y="2674620"/>
+            <a:ext cx="1356360" cy="175260"/>
+          </a:xfrm>
+          <a:prstGeom prst="rect">
+            <a:avLst/>
+          </a:prstGeom>
+          <a:noFill/>
+          <a:ln/>
+        </p:spPr>
+        <p:txBody>
+          <a:bodyPr wrap="square" lIns="0" tIns="0" rIns="0" bIns="0" rtlCol="0" anchor="ctr">
+            <a:normAutofit/>
+          </a:bodyPr>
+          <a:lstStyle/>
+          <a:p>
+            <a:pPr algn="l" indent="0" marL="0">
+              <a:buNone/>
+            </a:pPr>
+            <a:r>
+              <a:rPr lang="en-US" sz="780" b="1" spc="80" kern="0" dirty="0">
+                <a:solidFill>
+                  <a:srgbClr val="557DC0"/>
+                </a:solidFill>
+                <a:latin typeface="Aptos" pitchFamily="34" charset="0"/>
+                <a:ea typeface="Aptos" pitchFamily="34" charset="-122"/>
+                <a:cs typeface="Aptos" pitchFamily="34" charset="-120"/>
+              </a:rPr>
+              <a:t>OUTREACH</a:t>
+            </a:r>
+            <a:endParaRPr lang="en-US" sz="780" dirty="0"/>
+          </a:p>
+        </p:txBody>
+      </p:sp>
+      <p:sp>
+        <p:nvSpPr>
+          <p:cNvPr id="41" name="Text 39"/>
+          <p:cNvSpPr txBox="1"/>
+          <p:nvPr/>
+        </p:nvSpPr>
+        <p:spPr>
+          <a:xfrm>
+            <a:off x="10142220" y="2895600"/>
+            <a:ext cx="1356360" cy="167640"/>
+          </a:xfrm>
+          <a:prstGeom prst="rect">
+            <a:avLst/>
+          </a:prstGeom>
+          <a:noFill/>
+          <a:ln/>
+        </p:spPr>
+        <p:txBody>
+          <a:bodyPr wrap="square" lIns="0" tIns="0" rIns="0" bIns="0" rtlCol="0" anchor="ctr">
+            <a:normAutofit/>
+          </a:bodyPr>
+          <a:lstStyle/>
+          <a:p>
+            <a:pPr algn="l" indent="0" marL="0">
+              <a:buNone/>
+            </a:pPr>
+            <a:r>
+              <a:rPr lang="en-US" sz="660" b="1" dirty="0">
+                <a:solidFill>
+                  <a:srgbClr val="344258"/>
+                </a:solidFill>
+                <a:latin typeface="Aptos" pitchFamily="34" charset="0"/>
+                <a:ea typeface="Aptos" pitchFamily="34" charset="-122"/>
+                <a:cs typeface="Aptos" pitchFamily="34" charset="-120"/>
+              </a:rPr>
+              <a:t>Draft + approve</a:t>
+            </a:r>
+            <a:endParaRPr lang="en-US" sz="660" dirty="0"/>
+          </a:p>
+        </p:txBody>
+      </p:sp>
+      <p:sp>
+        <p:nvSpPr>
+          <p:cNvPr id="42" name="Shape 40"/>
+          <p:cNvSpPr/>
+          <p:nvPr/>
+        </p:nvSpPr>
+        <p:spPr>
+          <a:xfrm>
+            <a:off x="11620500" y="3185160"/>
+            <a:ext cx="0" cy="563880"/>
+          </a:xfrm>
+          <a:prstGeom prst="line">
+            <a:avLst/>
+          </a:prstGeom>
+          <a:noFill/>
+          <a:ln w="27940">
+            <a:solidFill>
+              <a:srgbClr val="557DC0"/>
+            </a:solidFill>
+            <a:prstDash val="solid"/>
+            <a:headEnd type="none"/>
+            <a:tailEnd type="triangle"/>
+          </a:ln>
+        </p:spPr>
+      </p:sp>
+      <p:sp>
+        <p:nvSpPr>
+          <p:cNvPr id="43" name="Shape 41"/>
+          <p:cNvSpPr/>
+          <p:nvPr/>
+        </p:nvSpPr>
+        <p:spPr>
+          <a:xfrm>
+            <a:off x="9715500" y="3467100"/>
+            <a:ext cx="1905000" cy="266700"/>
+          </a:xfrm>
+          <a:prstGeom prst="roundRect">
+            <a:avLst>
+              <a:gd name="adj" fmla="val 54857"/>
+            </a:avLst>
+          </a:prstGeom>
+          <a:solidFill>
+            <a:srgbClr val="E4F2ED"/>
+          </a:solidFill>
+          <a:ln w="6350">
+            <a:solidFill>
+              <a:srgbClr val="E4F2ED">
+                <a:alpha val="0"/>
+              </a:srgbClr>
+            </a:solidFill>
+            <a:prstDash val="solid"/>
+          </a:ln>
+        </p:spPr>
+      </p:sp>
+      <p:sp>
+        <p:nvSpPr>
+          <p:cNvPr id="44" name="Text 42"/>
+          <p:cNvSpPr txBox="1"/>
+          <p:nvPr/>
+        </p:nvSpPr>
+        <p:spPr>
+          <a:xfrm>
+            <a:off x="9791700" y="3489960"/>
+            <a:ext cx="1752600" cy="220980"/>
+          </a:xfrm>
+          <a:prstGeom prst="rect">
+            <a:avLst/>
+          </a:prstGeom>
+          <a:noFill/>
+          <a:ln/>
+        </p:spPr>
+        <p:txBody>
+          <a:bodyPr wrap="square" lIns="0" tIns="0" rIns="0" bIns="0" rtlCol="0" anchor="ctr">
+            <a:normAutofit/>
+          </a:bodyPr>
+          <a:lstStyle/>
+          <a:p>
+            <a:pPr algn="ctr" indent="0" marL="0">
+              <a:buNone/>
+            </a:pPr>
+            <a:r>
+              <a:rPr lang="en-US" sz="600" b="1" spc="30" kern="0" dirty="0">
+                <a:solidFill>
+                  <a:srgbClr val="2F8B72"/>
+                </a:solidFill>
+                <a:latin typeface="Aptos" pitchFamily="34" charset="0"/>
+                <a:ea typeface="Aptos" pitchFamily="34" charset="-122"/>
+                <a:cs typeface="Aptos" pitchFamily="34" charset="-120"/>
+              </a:rPr>
+              <a:t>INBOUND · RESPONSE</a:t>
+            </a:r>
+            <a:endParaRPr lang="en-US" sz="600" dirty="0"/>
+          </a:p>
+        </p:txBody>
+      </p:sp>
+      <p:sp>
+        <p:nvSpPr>
+          <p:cNvPr id="45" name="Shape 43"/>
+          <p:cNvSpPr/>
+          <p:nvPr/>
+        </p:nvSpPr>
+        <p:spPr>
+          <a:xfrm>
+            <a:off x="685800" y="3886200"/>
+            <a:ext cx="1905000" cy="883920"/>
+          </a:xfrm>
+          <a:prstGeom prst="roundRect">
+            <a:avLst>
+              <a:gd name="adj" fmla="val 14483"/>
+            </a:avLst>
+          </a:prstGeom>
+          <a:solidFill>
+            <a:srgbClr val="E4F2ED"/>
+          </a:solidFill>
+          <a:ln w="6350">
+            <a:solidFill>
+              <a:srgbClr val="E4F2ED">
+                <a:alpha val="0"/>
+              </a:srgbClr>
+            </a:solidFill>
+            <a:prstDash val="solid"/>
+          </a:ln>
+          <a:effectLst>
+            <a:outerShdw sx="100000" sy="100000" kx="0" ky="0" algn="bl" rotWithShape="0" blurRad="5.679133646942494e+57" dist="1.1358267293884988e+58" dir="3.526387384320001e+68">
+              <a:srgbClr val="405875">
+                <a:alpha val="1.2e+69"/>
+              </a:srgbClr>
+            </a:outerShdw>
+          </a:effectLst>
+        </p:spPr>
+      </p:sp>
+      <p:sp>
+        <p:nvSpPr>
+          <p:cNvPr id="46" name="Shape 44"/>
+          <p:cNvSpPr/>
+          <p:nvPr/>
+        </p:nvSpPr>
+        <p:spPr>
+          <a:xfrm>
+            <a:off x="807720" y="4000500"/>
+            <a:ext cx="320040" cy="213360"/>
+          </a:xfrm>
+          <a:prstGeom prst="roundRect">
+            <a:avLst>
+              <a:gd name="adj" fmla="val 68571"/>
+            </a:avLst>
+          </a:prstGeom>
+          <a:solidFill>
+            <a:srgbClr val="FFFFFF"/>
+          </a:solidFill>
+          <a:ln w="6350">
+            <a:solidFill>
+              <a:srgbClr val="FFFFFF">
+                <a:alpha val="0"/>
+              </a:srgbClr>
+            </a:solidFill>
+            <a:prstDash val="solid"/>
+          </a:ln>
+        </p:spPr>
+      </p:sp>
+      <p:sp>
+        <p:nvSpPr>
+          <p:cNvPr id="47" name="Text 45"/>
+          <p:cNvSpPr txBox="1"/>
+          <p:nvPr/>
+        </p:nvSpPr>
+        <p:spPr>
+          <a:xfrm>
+            <a:off x="883920" y="4023360"/>
+            <a:ext cx="167640" cy="167640"/>
+          </a:xfrm>
+          <a:prstGeom prst="rect">
+            <a:avLst/>
+          </a:prstGeom>
+          <a:noFill/>
+          <a:ln/>
+        </p:spPr>
+        <p:txBody>
+          <a:bodyPr wrap="square" lIns="0" tIns="0" rIns="0" bIns="0" rtlCol="0" anchor="ctr">
+            <a:normAutofit/>
+          </a:bodyPr>
+          <a:lstStyle/>
+          <a:p>
+            <a:pPr algn="ctr" indent="0" marL="0">
+              <a:buNone/>
+            </a:pPr>
+            <a:r>
+              <a:rPr lang="en-US" sz="540" b="1" spc="30" kern="0" dirty="0">
+                <a:solidFill>
+                  <a:srgbClr val="2F8B72"/>
+                </a:solidFill>
+                <a:latin typeface="Aptos" pitchFamily="34" charset="0"/>
+                <a:ea typeface="Aptos" pitchFamily="34" charset="-122"/>
+                <a:cs typeface="Aptos" pitchFamily="34" charset="-120"/>
+              </a:rPr>
+              <a:t>11</a:t>
+            </a:r>
+            <a:endParaRPr lang="en-US" sz="540" dirty="0"/>
+          </a:p>
+        </p:txBody>
+      </p:sp>
+      <p:sp>
+        <p:nvSpPr>
+          <p:cNvPr id="48" name="Text 46"/>
+          <p:cNvSpPr txBox="1"/>
+          <p:nvPr/>
+        </p:nvSpPr>
+        <p:spPr>
+          <a:xfrm>
+            <a:off x="807720" y="4274820"/>
+            <a:ext cx="1661160" cy="175260"/>
+          </a:xfrm>
+          <a:prstGeom prst="rect">
+            <a:avLst/>
+          </a:prstGeom>
+          <a:noFill/>
+          <a:ln/>
+        </p:spPr>
+        <p:txBody>
+          <a:bodyPr wrap="square" lIns="0" tIns="0" rIns="0" bIns="0" rtlCol="0" anchor="ctr">
+            <a:normAutofit/>
+          </a:bodyPr>
+          <a:lstStyle/>
+          <a:p>
+            <a:pPr algn="l" indent="0" marL="0">
+              <a:buNone/>
+            </a:pPr>
+            <a:r>
+              <a:rPr lang="en-US" sz="780" b="1" spc="70" kern="0" dirty="0">
+                <a:solidFill>
+                  <a:srgbClr val="2F8B72"/>
+                </a:solidFill>
+                <a:latin typeface="Aptos" pitchFamily="34" charset="0"/>
+                <a:ea typeface="Aptos" pitchFamily="34" charset="-122"/>
+                <a:cs typeface="Aptos" pitchFamily="34" charset="-120"/>
+              </a:rPr>
+              <a:t>RECOMMEND</a:t>
+            </a:r>
+            <a:endParaRPr lang="en-US" sz="780" dirty="0"/>
+          </a:p>
+        </p:txBody>
+      </p:sp>
+      <p:sp>
+        <p:nvSpPr>
+          <p:cNvPr id="49" name="Text 47"/>
+          <p:cNvSpPr txBox="1"/>
+          <p:nvPr/>
+        </p:nvSpPr>
+        <p:spPr>
+          <a:xfrm>
+            <a:off x="807720" y="4495800"/>
+            <a:ext cx="1661160" cy="167640"/>
+          </a:xfrm>
+          <a:prstGeom prst="rect">
+            <a:avLst/>
+          </a:prstGeom>
+          <a:noFill/>
+          <a:ln/>
+        </p:spPr>
+        <p:txBody>
+          <a:bodyPr wrap="square" lIns="0" tIns="0" rIns="0" bIns="0" rtlCol="0" anchor="ctr">
+            <a:normAutofit/>
+          </a:bodyPr>
+          <a:lstStyle/>
+          <a:p>
+            <a:pPr algn="l" indent="0" marL="0">
+              <a:buNone/>
+            </a:pPr>
+            <a:r>
+              <a:rPr lang="en-US" sz="660" b="1" dirty="0">
+                <a:solidFill>
+                  <a:srgbClr val="344258"/>
+                </a:solidFill>
+                <a:latin typeface="Aptos" pitchFamily="34" charset="0"/>
+                <a:ea typeface="Aptos" pitchFamily="34" charset="-122"/>
+                <a:cs typeface="Aptos" pitchFamily="34" charset="-120"/>
+              </a:rPr>
+              <a:t>Proceed · Hold · Decline</a:t>
+            </a:r>
+            <a:endParaRPr lang="en-US" sz="660" dirty="0"/>
+          </a:p>
+        </p:txBody>
+      </p:sp>
+      <p:sp>
+        <p:nvSpPr>
+          <p:cNvPr id="50" name="Shape 48"/>
+          <p:cNvSpPr/>
+          <p:nvPr/>
+        </p:nvSpPr>
+        <p:spPr>
+          <a:xfrm>
+            <a:off x="2895600" y="4328160"/>
+            <a:ext cx="-274320" cy="0"/>
+          </a:xfrm>
+          <a:prstGeom prst="line">
+            <a:avLst/>
+          </a:prstGeom>
+          <a:noFill/>
+          <a:ln w="22860">
+            <a:solidFill>
+              <a:srgbClr val="2F8B72"/>
+            </a:solidFill>
+            <a:prstDash val="solid"/>
+            <a:headEnd type="none"/>
+            <a:tailEnd type="triangle"/>
+          </a:ln>
+        </p:spPr>
+      </p:sp>
+      <p:sp>
+        <p:nvSpPr>
+          <p:cNvPr id="51" name="Shape 49"/>
+          <p:cNvSpPr/>
+          <p:nvPr/>
+        </p:nvSpPr>
+        <p:spPr>
+          <a:xfrm>
+            <a:off x="2926080" y="3886200"/>
+            <a:ext cx="1905000" cy="883920"/>
+          </a:xfrm>
+          <a:prstGeom prst="roundRect">
+            <a:avLst>
+              <a:gd name="adj" fmla="val 14483"/>
+            </a:avLst>
+          </a:prstGeom>
+          <a:solidFill>
+            <a:srgbClr val="EEE8F8"/>
+          </a:solidFill>
+          <a:ln w="6350">
+            <a:solidFill>
+              <a:srgbClr val="EEE8F8">
+                <a:alpha val="0"/>
+              </a:srgbClr>
+            </a:solidFill>
+            <a:prstDash val="solid"/>
+          </a:ln>
+        </p:spPr>
+      </p:sp>
+      <p:sp>
+        <p:nvSpPr>
+          <p:cNvPr id="52" name="Shape 50"/>
+          <p:cNvSpPr/>
+          <p:nvPr/>
+        </p:nvSpPr>
+        <p:spPr>
+          <a:xfrm>
+            <a:off x="3048000" y="4000500"/>
+            <a:ext cx="320040" cy="213360"/>
+          </a:xfrm>
+          <a:prstGeom prst="roundRect">
+            <a:avLst>
+              <a:gd name="adj" fmla="val 68571"/>
+            </a:avLst>
+          </a:prstGeom>
+          <a:solidFill>
+            <a:srgbClr val="FFFFFF"/>
+          </a:solidFill>
+          <a:ln w="6350">
+            <a:solidFill>
+              <a:srgbClr val="FFFFFF">
+                <a:alpha val="0"/>
+              </a:srgbClr>
+            </a:solidFill>
+            <a:prstDash val="solid"/>
+          </a:ln>
+        </p:spPr>
+      </p:sp>
+      <p:sp>
+        <p:nvSpPr>
+          <p:cNvPr id="53" name="Text 51"/>
+          <p:cNvSpPr txBox="1"/>
+          <p:nvPr/>
+        </p:nvSpPr>
+        <p:spPr>
+          <a:xfrm>
+            <a:off x="3124200" y="4023360"/>
+            <a:ext cx="167640" cy="167640"/>
+          </a:xfrm>
+          <a:prstGeom prst="rect">
+            <a:avLst/>
+          </a:prstGeom>
+          <a:noFill/>
+          <a:ln/>
+        </p:spPr>
+        <p:txBody>
+          <a:bodyPr wrap="square" lIns="0" tIns="0" rIns="0" bIns="0" rtlCol="0" anchor="ctr">
+            <a:normAutofit/>
+          </a:bodyPr>
+          <a:lstStyle/>
+          <a:p>
+            <a:pPr algn="ctr" indent="0" marL="0">
+              <a:buNone/>
+            </a:pPr>
+            <a:r>
+              <a:rPr lang="en-US" sz="540" b="1" spc="30" kern="0" dirty="0">
+                <a:solidFill>
+                  <a:srgbClr val="7656A5"/>
+                </a:solidFill>
+                <a:latin typeface="Aptos" pitchFamily="34" charset="0"/>
+                <a:ea typeface="Aptos" pitchFamily="34" charset="-122"/>
+                <a:cs typeface="Aptos" pitchFamily="34" charset="-120"/>
+              </a:rPr>
+              <a:t>10</a:t>
+            </a:r>
+            <a:endParaRPr lang="en-US" sz="540" dirty="0"/>
+          </a:p>
+        </p:txBody>
+      </p:sp>
+      <p:sp>
+        <p:nvSpPr>
+          <p:cNvPr id="54" name="Text 52"/>
+          <p:cNvSpPr txBox="1"/>
+          <p:nvPr/>
+        </p:nvSpPr>
+        <p:spPr>
+          <a:xfrm>
+            <a:off x="3048000" y="4274820"/>
+            <a:ext cx="1661160" cy="175260"/>
+          </a:xfrm>
+          <a:prstGeom prst="rect">
+            <a:avLst/>
+          </a:prstGeom>
+          <a:noFill/>
+          <a:ln/>
+        </p:spPr>
+        <p:txBody>
+          <a:bodyPr wrap="square" lIns="0" tIns="0" rIns="0" bIns="0" rtlCol="0" anchor="ctr">
+            <a:normAutofit/>
+          </a:bodyPr>
+          <a:lstStyle/>
+          <a:p>
+            <a:pPr algn="l" indent="0" marL="0">
+              <a:buNone/>
+            </a:pPr>
+            <a:r>
+              <a:rPr lang="en-US" sz="780" b="1" spc="70" kern="0" dirty="0">
+                <a:solidFill>
+                  <a:srgbClr val="7656A5"/>
+                </a:solidFill>
+                <a:latin typeface="Aptos" pitchFamily="34" charset="0"/>
+                <a:ea typeface="Aptos" pitchFamily="34" charset="-122"/>
+                <a:cs typeface="Aptos" pitchFamily="34" charset="-120"/>
+              </a:rPr>
+              <a:t>RE-SCORE</a:t>
+            </a:r>
+            <a:endParaRPr lang="en-US" sz="780" dirty="0"/>
+          </a:p>
+        </p:txBody>
+      </p:sp>
+      <p:sp>
+        <p:nvSpPr>
+          <p:cNvPr id="55" name="Text 53"/>
+          <p:cNvSpPr txBox="1"/>
+          <p:nvPr/>
+        </p:nvSpPr>
+        <p:spPr>
+          <a:xfrm>
+            <a:off x="3048000" y="4495800"/>
+            <a:ext cx="1661160" cy="167640"/>
+          </a:xfrm>
+          <a:prstGeom prst="rect">
+            <a:avLst/>
+          </a:prstGeom>
+          <a:noFill/>
+          <a:ln/>
+        </p:spPr>
+        <p:txBody>
+          <a:bodyPr wrap="square" lIns="0" tIns="0" rIns="0" bIns="0" rtlCol="0" anchor="ctr">
+            <a:normAutofit/>
+          </a:bodyPr>
+          <a:lstStyle/>
+          <a:p>
+            <a:pPr algn="l" indent="0" marL="0">
+              <a:buNone/>
+            </a:pPr>
+            <a:r>
+              <a:rPr lang="en-US" sz="660" b="1" dirty="0">
+                <a:solidFill>
+                  <a:srgbClr val="344258"/>
+                </a:solidFill>
+                <a:latin typeface="Aptos" pitchFamily="34" charset="0"/>
+                <a:ea typeface="Aptos" pitchFamily="34" charset="-122"/>
+                <a:cs typeface="Aptos" pitchFamily="34" charset="-120"/>
+              </a:rPr>
+              <a:t>Axes + SWOT + trend</a:t>
+            </a:r>
+            <a:endParaRPr lang="en-US" sz="660" dirty="0"/>
+          </a:p>
+        </p:txBody>
+      </p:sp>
+      <p:sp>
+        <p:nvSpPr>
+          <p:cNvPr id="56" name="Shape 54"/>
+          <p:cNvSpPr/>
+          <p:nvPr/>
+        </p:nvSpPr>
+        <p:spPr>
+          <a:xfrm>
+            <a:off x="5135880" y="4328160"/>
+            <a:ext cx="-274320" cy="0"/>
+          </a:xfrm>
+          <a:prstGeom prst="line">
+            <a:avLst/>
+          </a:prstGeom>
+          <a:noFill/>
+          <a:ln w="22860">
+            <a:solidFill>
+              <a:srgbClr val="7656A5"/>
+            </a:solidFill>
+            <a:prstDash val="solid"/>
+            <a:headEnd type="none"/>
+            <a:tailEnd type="triangle"/>
+          </a:ln>
+        </p:spPr>
+      </p:sp>
+      <p:sp>
+        <p:nvSpPr>
+          <p:cNvPr id="57" name="Shape 55"/>
+          <p:cNvSpPr/>
+          <p:nvPr/>
+        </p:nvSpPr>
+        <p:spPr>
+          <a:xfrm>
+            <a:off x="5166360" y="3886200"/>
+            <a:ext cx="1905000" cy="883920"/>
+          </a:xfrm>
+          <a:prstGeom prst="roundRect">
+            <a:avLst>
+              <a:gd name="adj" fmla="val 14483"/>
             </a:avLst>
           </a:prstGeom>
           <a:solidFill>
@@ -12039,18 +13092,18 @@
       </p:sp>
       <p:sp>
         <p:nvSpPr>
-          <p:cNvPr id="27" name="Shape 25"/>
-          <p:cNvSpPr/>
-          <p:nvPr/>
-        </p:nvSpPr>
-        <p:spPr>
-          <a:xfrm>
-            <a:off x="5181600" y="2491740"/>
-            <a:ext cx="365760" cy="259080"/>
+          <p:cNvPr id="58" name="Shape 56"/>
+          <p:cNvSpPr/>
+          <p:nvPr/>
+        </p:nvSpPr>
+        <p:spPr>
+          <a:xfrm>
+            <a:off x="5288280" y="4000500"/>
+            <a:ext cx="320040" cy="213360"/>
           </a:xfrm>
           <a:prstGeom prst="roundRect">
             <a:avLst>
-              <a:gd name="adj" fmla="val 56471"/>
+              <a:gd name="adj" fmla="val 68571"/>
             </a:avLst>
           </a:prstGeom>
           <a:solidFill>
@@ -12068,14 +13121,14 @@
       </p:sp>
       <p:sp>
         <p:nvSpPr>
-          <p:cNvPr id="28" name="Text 26"/>
-          <p:cNvSpPr txBox="1"/>
-          <p:nvPr/>
-        </p:nvSpPr>
-        <p:spPr>
-          <a:xfrm>
-            <a:off x="5257800" y="2514600"/>
-            <a:ext cx="213360" cy="213360"/>
+          <p:cNvPr id="59" name="Text 57"/>
+          <p:cNvSpPr txBox="1"/>
+          <p:nvPr/>
+        </p:nvSpPr>
+        <p:spPr>
+          <a:xfrm>
+            <a:off x="5364480" y="4023360"/>
+            <a:ext cx="167640" cy="167640"/>
           </a:xfrm>
           <a:prstGeom prst="rect">
             <a:avLst/>
@@ -12093,7 +13146,7 @@
               <a:buNone/>
             </a:pPr>
             <a:r>
-              <a:rPr lang="en-US" sz="600" b="1" spc="30" kern="0" dirty="0">
+              <a:rPr lang="en-US" sz="540" b="1" spc="30" kern="0" dirty="0">
                 <a:solidFill>
                   <a:srgbClr val="557DC0"/>
                 </a:solidFill>
@@ -12101,89 +13154,48 @@
                 <a:ea typeface="Aptos" pitchFamily="34" charset="-122"/>
                 <a:cs typeface="Aptos" pitchFamily="34" charset="-120"/>
               </a:rPr>
-              <a:t>01</a:t>
-            </a:r>
-            <a:endParaRPr lang="en-US" sz="600" dirty="0"/>
-          </a:p>
-        </p:txBody>
-      </p:sp>
-      <p:sp>
-        <p:nvSpPr>
-          <p:cNvPr id="29" name="Text 27"/>
-          <p:cNvSpPr txBox="1"/>
-          <p:nvPr/>
-        </p:nvSpPr>
-        <p:spPr>
-          <a:xfrm>
-            <a:off x="5715000" y="2446020"/>
-            <a:ext cx="1905000" cy="182880"/>
-          </a:xfrm>
-          <a:prstGeom prst="rect">
-            <a:avLst/>
-          </a:prstGeom>
-          <a:noFill/>
-          <a:ln/>
-        </p:spPr>
-        <p:txBody>
-          <a:bodyPr wrap="square" lIns="0" tIns="0" rIns="0" bIns="0" rtlCol="0" anchor="ctr">
-            <a:normAutofit/>
-          </a:bodyPr>
-          <a:lstStyle/>
-          <a:p>
-            <a:pPr algn="l" indent="0" marL="0">
-              <a:buNone/>
-            </a:pPr>
-            <a:r>
-              <a:rPr lang="en-US" sz="960" b="1" dirty="0">
-                <a:solidFill>
-                  <a:srgbClr val="172337"/>
-                </a:solidFill>
-                <a:latin typeface="Aptos" pitchFamily="34" charset="0"/>
-                <a:ea typeface="Aptos" pitchFamily="34" charset="-122"/>
-                <a:cs typeface="Aptos" pitchFamily="34" charset="-120"/>
-              </a:rPr>
-              <a:t>Investor SPA</a:t>
-            </a:r>
-            <a:endParaRPr lang="en-US" sz="960" dirty="0"/>
-          </a:p>
-        </p:txBody>
-      </p:sp>
-      <p:sp>
-        <p:nvSpPr>
-          <p:cNvPr id="30" name="Text 28"/>
-          <p:cNvSpPr txBox="1"/>
-          <p:nvPr/>
-        </p:nvSpPr>
-        <p:spPr>
-          <a:xfrm>
-            <a:off x="7658100" y="2461260"/>
-            <a:ext cx="3276600" cy="182880"/>
-          </a:xfrm>
-          <a:prstGeom prst="rect">
-            <a:avLst/>
-          </a:prstGeom>
-          <a:noFill/>
-          <a:ln/>
-        </p:spPr>
-        <p:txBody>
-          <a:bodyPr wrap="square" lIns="0" tIns="0" rIns="0" bIns="0" rtlCol="0" anchor="ctr">
-            <a:normAutofit/>
-          </a:bodyPr>
-          <a:lstStyle/>
-          <a:p>
-            <a:pPr algn="r" indent="0" marL="0">
-              <a:buNone/>
-            </a:pPr>
-            <a:r>
-              <a:rPr lang="en-US" sz="780" dirty="0">
-                <a:solidFill>
-                  <a:srgbClr val="718097"/>
-                </a:solidFill>
-                <a:latin typeface="Aptos" pitchFamily="34" charset="0"/>
-                <a:ea typeface="Aptos" pitchFamily="34" charset="-122"/>
-                <a:cs typeface="Aptos" pitchFamily="34" charset="-120"/>
-              </a:rPr>
-              <a:t>React UI + evidence drill-down</a:t>
+              <a:t>09</a:t>
+            </a:r>
+            <a:endParaRPr lang="en-US" sz="540" dirty="0"/>
+          </a:p>
+        </p:txBody>
+      </p:sp>
+      <p:sp>
+        <p:nvSpPr>
+          <p:cNvPr id="60" name="Text 58"/>
+          <p:cNvSpPr txBox="1"/>
+          <p:nvPr/>
+        </p:nvSpPr>
+        <p:spPr>
+          <a:xfrm>
+            <a:off x="5288280" y="4274820"/>
+            <a:ext cx="1661160" cy="175260"/>
+          </a:xfrm>
+          <a:prstGeom prst="rect">
+            <a:avLst/>
+          </a:prstGeom>
+          <a:noFill/>
+          <a:ln/>
+        </p:spPr>
+        <p:txBody>
+          <a:bodyPr wrap="square" lIns="0" tIns="0" rIns="0" bIns="0" rtlCol="0" anchor="ctr">
+            <a:normAutofit/>
+          </a:bodyPr>
+          <a:lstStyle/>
+          <a:p>
+            <a:pPr algn="l" indent="0" marL="0">
+              <a:buNone/>
+            </a:pPr>
+            <a:r>
+              <a:rPr lang="en-US" sz="780" b="1" spc="70" kern="0" dirty="0">
+                <a:solidFill>
+                  <a:srgbClr val="557DC0"/>
+                </a:solidFill>
+                <a:latin typeface="Aptos" pitchFamily="34" charset="0"/>
+                <a:ea typeface="Aptos" pitchFamily="34" charset="-122"/>
+                <a:cs typeface="Aptos" pitchFamily="34" charset="-120"/>
+              </a:rPr>
+              <a:t>EVIDENCE GRAPH</a:t>
             </a:r>
             <a:endParaRPr lang="en-US" sz="780" dirty="0"/>
           </a:p>
@@ -12191,67 +13203,92 @@
       </p:sp>
       <p:sp>
         <p:nvSpPr>
-          <p:cNvPr id="31" name="Text 29"/>
-          <p:cNvSpPr txBox="1"/>
-          <p:nvPr/>
-        </p:nvSpPr>
-        <p:spPr>
-          <a:xfrm>
-            <a:off x="8077200" y="2827020"/>
-            <a:ext cx="304800" cy="182880"/>
-          </a:xfrm>
-          <a:prstGeom prst="rect">
-            <a:avLst/>
-          </a:prstGeom>
-          <a:noFill/>
-          <a:ln/>
-        </p:spPr>
-        <p:txBody>
-          <a:bodyPr wrap="square" lIns="0" tIns="0" rIns="0" bIns="0" rtlCol="0" anchor="ctr">
-            <a:normAutofit/>
-          </a:bodyPr>
-          <a:lstStyle/>
-          <a:p>
-            <a:pPr algn="ctr" indent="0" marL="0">
-              <a:buNone/>
-            </a:pPr>
-            <a:r>
-              <a:rPr lang="en-US" sz="960" b="1" dirty="0">
-                <a:solidFill>
-                  <a:srgbClr val="557DC0"/>
-                </a:solidFill>
-                <a:latin typeface="Aptos" pitchFamily="34" charset="0"/>
-                <a:ea typeface="Aptos" pitchFamily="34" charset="-122"/>
-                <a:cs typeface="Aptos" pitchFamily="34" charset="-120"/>
-              </a:rPr>
-              <a:t>↓</a:t>
-            </a:r>
-            <a:endParaRPr lang="en-US" sz="960" dirty="0"/>
-          </a:p>
-        </p:txBody>
-      </p:sp>
-      <p:sp>
-        <p:nvSpPr>
-          <p:cNvPr id="32" name="Shape 30"/>
-          <p:cNvSpPr/>
-          <p:nvPr/>
-        </p:nvSpPr>
-        <p:spPr>
-          <a:xfrm>
-            <a:off x="5067300" y="2994660"/>
-            <a:ext cx="6134100" cy="441960"/>
+          <p:cNvPr id="61" name="Text 59"/>
+          <p:cNvSpPr txBox="1"/>
+          <p:nvPr/>
+        </p:nvSpPr>
+        <p:spPr>
+          <a:xfrm>
+            <a:off x="5288280" y="4495800"/>
+            <a:ext cx="1661160" cy="167640"/>
+          </a:xfrm>
+          <a:prstGeom prst="rect">
+            <a:avLst/>
+          </a:prstGeom>
+          <a:noFill/>
+          <a:ln/>
+        </p:spPr>
+        <p:txBody>
+          <a:bodyPr wrap="square" lIns="0" tIns="0" rIns="0" bIns="0" rtlCol="0" anchor="ctr">
+            <a:normAutofit/>
+          </a:bodyPr>
+          <a:lstStyle/>
+          <a:p>
+            <a:pPr algn="l" indent="0" marL="0">
+              <a:buNone/>
+            </a:pPr>
+            <a:r>
+              <a:rPr lang="en-US" sz="660" b="1" dirty="0">
+                <a:solidFill>
+                  <a:srgbClr val="344258"/>
+                </a:solidFill>
+                <a:latin typeface="Aptos" pitchFamily="34" charset="0"/>
+                <a:ea typeface="Aptos" pitchFamily="34" charset="-122"/>
+                <a:cs typeface="Aptos" pitchFamily="34" charset="-120"/>
+              </a:rPr>
+              <a:t>Claims + provenance</a:t>
+            </a:r>
+            <a:endParaRPr lang="en-US" sz="660" dirty="0"/>
+          </a:p>
+        </p:txBody>
+      </p:sp>
+      <p:sp>
+        <p:nvSpPr>
+          <p:cNvPr id="62" name="Shape 60"/>
+          <p:cNvSpPr/>
+          <p:nvPr/>
+        </p:nvSpPr>
+        <p:spPr>
+          <a:xfrm>
+            <a:off x="7376160" y="4328160"/>
+            <a:ext cx="-274320" cy="0"/>
+          </a:xfrm>
+          <a:prstGeom prst="line">
+            <a:avLst/>
+          </a:prstGeom>
+          <a:noFill/>
+          <a:ln w="22860">
+            <a:solidFill>
+              <a:srgbClr val="557DC0"/>
+            </a:solidFill>
+            <a:prstDash val="solid"/>
+            <a:headEnd type="none"/>
+            <a:tailEnd type="triangle"/>
+          </a:ln>
+        </p:spPr>
+      </p:sp>
+      <p:sp>
+        <p:nvSpPr>
+          <p:cNvPr id="63" name="Shape 61"/>
+          <p:cNvSpPr/>
+          <p:nvPr/>
+        </p:nvSpPr>
+        <p:spPr>
+          <a:xfrm>
+            <a:off x="7406640" y="3886200"/>
+            <a:ext cx="1905000" cy="883920"/>
           </a:xfrm>
           <a:prstGeom prst="roundRect">
             <a:avLst>
-              <a:gd name="adj" fmla="val 24828"/>
+              <a:gd name="adj" fmla="val 14483"/>
             </a:avLst>
           </a:prstGeom>
           <a:solidFill>
-            <a:srgbClr val="EEE8F8"/>
+            <a:srgbClr val="FFF1DF"/>
           </a:solidFill>
           <a:ln w="6350">
             <a:solidFill>
-              <a:srgbClr val="EEE8F8">
+              <a:srgbClr val="FFF1DF">
                 <a:alpha val="0"/>
               </a:srgbClr>
             </a:solidFill>
@@ -12261,18 +13298,18 @@
       </p:sp>
       <p:sp>
         <p:nvSpPr>
-          <p:cNvPr id="33" name="Shape 31"/>
-          <p:cNvSpPr/>
-          <p:nvPr/>
-        </p:nvSpPr>
-        <p:spPr>
-          <a:xfrm>
-            <a:off x="5181600" y="3086100"/>
-            <a:ext cx="365760" cy="259080"/>
+          <p:cNvPr id="64" name="Shape 62"/>
+          <p:cNvSpPr/>
+          <p:nvPr/>
+        </p:nvSpPr>
+        <p:spPr>
+          <a:xfrm>
+            <a:off x="7528560" y="4000500"/>
+            <a:ext cx="320040" cy="213360"/>
           </a:xfrm>
           <a:prstGeom prst="roundRect">
             <a:avLst>
-              <a:gd name="adj" fmla="val 56471"/>
+              <a:gd name="adj" fmla="val 68571"/>
             </a:avLst>
           </a:prstGeom>
           <a:solidFill>
@@ -12290,14 +13327,14 @@
       </p:sp>
       <p:sp>
         <p:nvSpPr>
-          <p:cNvPr id="34" name="Text 32"/>
-          <p:cNvSpPr txBox="1"/>
-          <p:nvPr/>
-        </p:nvSpPr>
-        <p:spPr>
-          <a:xfrm>
-            <a:off x="5257800" y="3108960"/>
-            <a:ext cx="213360" cy="213360"/>
+          <p:cNvPr id="65" name="Text 63"/>
+          <p:cNvSpPr txBox="1"/>
+          <p:nvPr/>
+        </p:nvSpPr>
+        <p:spPr>
+          <a:xfrm>
+            <a:off x="7604760" y="4023360"/>
+            <a:ext cx="167640" cy="167640"/>
           </a:xfrm>
           <a:prstGeom prst="rect">
             <a:avLst/>
@@ -12315,97 +13352,56 @@
               <a:buNone/>
             </a:pPr>
             <a:r>
-              <a:rPr lang="en-US" sz="600" b="1" spc="30" kern="0" dirty="0">
-                <a:solidFill>
-                  <a:srgbClr val="7656A5"/>
-                </a:solidFill>
-                <a:latin typeface="Aptos" pitchFamily="34" charset="0"/>
-                <a:ea typeface="Aptos" pitchFamily="34" charset="-122"/>
-                <a:cs typeface="Aptos" pitchFamily="34" charset="-120"/>
-              </a:rPr>
-              <a:t>02</a:t>
-            </a:r>
-            <a:endParaRPr lang="en-US" sz="600" dirty="0"/>
-          </a:p>
-        </p:txBody>
-      </p:sp>
-      <p:sp>
-        <p:nvSpPr>
-          <p:cNvPr id="35" name="Text 33"/>
-          <p:cNvSpPr txBox="1"/>
-          <p:nvPr/>
-        </p:nvSpPr>
-        <p:spPr>
-          <a:xfrm>
-            <a:off x="5715000" y="3040380"/>
-            <a:ext cx="1905000" cy="182880"/>
-          </a:xfrm>
-          <a:prstGeom prst="rect">
-            <a:avLst/>
-          </a:prstGeom>
-          <a:noFill/>
-          <a:ln/>
-        </p:spPr>
-        <p:txBody>
-          <a:bodyPr wrap="square" lIns="0" tIns="0" rIns="0" bIns="0" rtlCol="0" anchor="ctr">
-            <a:normAutofit/>
-          </a:bodyPr>
-          <a:lstStyle/>
-          <a:p>
-            <a:pPr algn="l" indent="0" marL="0">
-              <a:buNone/>
-            </a:pPr>
-            <a:r>
-              <a:rPr lang="en-US" sz="960" b="1" dirty="0">
-                <a:solidFill>
-                  <a:srgbClr val="172337"/>
-                </a:solidFill>
-                <a:latin typeface="Aptos" pitchFamily="34" charset="0"/>
-                <a:ea typeface="Aptos" pitchFamily="34" charset="-122"/>
-                <a:cs typeface="Aptos" pitchFamily="34" charset="-120"/>
-              </a:rPr>
-              <a:t>FastAPI core</a:t>
-            </a:r>
-            <a:endParaRPr lang="en-US" sz="960" dirty="0"/>
-          </a:p>
-        </p:txBody>
-      </p:sp>
-      <p:sp>
-        <p:nvSpPr>
-          <p:cNvPr id="36" name="Text 34"/>
-          <p:cNvSpPr txBox="1"/>
-          <p:nvPr/>
-        </p:nvSpPr>
-        <p:spPr>
-          <a:xfrm>
-            <a:off x="7658100" y="3055620"/>
-            <a:ext cx="3276600" cy="182880"/>
-          </a:xfrm>
-          <a:prstGeom prst="rect">
-            <a:avLst/>
-          </a:prstGeom>
-          <a:noFill/>
-          <a:ln/>
-        </p:spPr>
-        <p:txBody>
-          <a:bodyPr wrap="square" lIns="0" tIns="0" rIns="0" bIns="0" rtlCol="0" anchor="ctr">
-            <a:normAutofit/>
-          </a:bodyPr>
-          <a:lstStyle/>
-          <a:p>
-            <a:pPr algn="r" indent="0" marL="0">
-              <a:buNone/>
-            </a:pPr>
-            <a:r>
-              <a:rPr lang="en-US" sz="780" dirty="0">
-                <a:solidFill>
-                  <a:srgbClr val="718097"/>
-                </a:solidFill>
-                <a:latin typeface="Aptos" pitchFamily="34" charset="0"/>
-                <a:ea typeface="Aptos" pitchFamily="34" charset="-122"/>
-                <a:cs typeface="Aptos" pitchFamily="34" charset="-120"/>
-              </a:rPr>
-              <a:t>Identity, claims, scores, decisions</a:t>
+              <a:rPr lang="en-US" sz="540" b="1" spc="30" kern="0" dirty="0">
+                <a:solidFill>
+                  <a:srgbClr val="B87932"/>
+                </a:solidFill>
+                <a:latin typeface="Aptos" pitchFamily="34" charset="0"/>
+                <a:ea typeface="Aptos" pitchFamily="34" charset="-122"/>
+                <a:cs typeface="Aptos" pitchFamily="34" charset="-120"/>
+              </a:rPr>
+              <a:t>08</a:t>
+            </a:r>
+            <a:endParaRPr lang="en-US" sz="540" dirty="0"/>
+          </a:p>
+        </p:txBody>
+      </p:sp>
+      <p:sp>
+        <p:nvSpPr>
+          <p:cNvPr id="66" name="Text 64"/>
+          <p:cNvSpPr txBox="1"/>
+          <p:nvPr/>
+        </p:nvSpPr>
+        <p:spPr>
+          <a:xfrm>
+            <a:off x="7528560" y="4274820"/>
+            <a:ext cx="1661160" cy="175260"/>
+          </a:xfrm>
+          <a:prstGeom prst="rect">
+            <a:avLst/>
+          </a:prstGeom>
+          <a:noFill/>
+          <a:ln/>
+        </p:spPr>
+        <p:txBody>
+          <a:bodyPr wrap="square" lIns="0" tIns="0" rIns="0" bIns="0" rtlCol="0" anchor="ctr">
+            <a:normAutofit/>
+          </a:bodyPr>
+          <a:lstStyle/>
+          <a:p>
+            <a:pPr algn="l" indent="0" marL="0">
+              <a:buNone/>
+            </a:pPr>
+            <a:r>
+              <a:rPr lang="en-US" sz="780" b="1" spc="70" kern="0" dirty="0">
+                <a:solidFill>
+                  <a:srgbClr val="B87932"/>
+                </a:solidFill>
+                <a:latin typeface="Aptos" pitchFamily="34" charset="0"/>
+                <a:ea typeface="Aptos" pitchFamily="34" charset="-122"/>
+                <a:cs typeface="Aptos" pitchFamily="34" charset="-120"/>
+              </a:rPr>
+              <a:t>DECK AGENT</a:t>
             </a:r>
             <a:endParaRPr lang="en-US" sz="780" dirty="0"/>
           </a:p>
@@ -12413,67 +13409,92 @@
       </p:sp>
       <p:sp>
         <p:nvSpPr>
-          <p:cNvPr id="37" name="Text 35"/>
-          <p:cNvSpPr txBox="1"/>
-          <p:nvPr/>
-        </p:nvSpPr>
-        <p:spPr>
-          <a:xfrm>
-            <a:off x="8077200" y="3421380"/>
-            <a:ext cx="304800" cy="182880"/>
-          </a:xfrm>
-          <a:prstGeom prst="rect">
-            <a:avLst/>
-          </a:prstGeom>
-          <a:noFill/>
-          <a:ln/>
-        </p:spPr>
-        <p:txBody>
-          <a:bodyPr wrap="square" lIns="0" tIns="0" rIns="0" bIns="0" rtlCol="0" anchor="ctr">
-            <a:normAutofit/>
-          </a:bodyPr>
-          <a:lstStyle/>
-          <a:p>
-            <a:pPr algn="ctr" indent="0" marL="0">
-              <a:buNone/>
-            </a:pPr>
-            <a:r>
-              <a:rPr lang="en-US" sz="960" b="1" dirty="0">
-                <a:solidFill>
-                  <a:srgbClr val="7656A5"/>
-                </a:solidFill>
-                <a:latin typeface="Aptos" pitchFamily="34" charset="0"/>
-                <a:ea typeface="Aptos" pitchFamily="34" charset="-122"/>
-                <a:cs typeface="Aptos" pitchFamily="34" charset="-120"/>
-              </a:rPr>
-              <a:t>↓</a:t>
-            </a:r>
-            <a:endParaRPr lang="en-US" sz="960" dirty="0"/>
-          </a:p>
-        </p:txBody>
-      </p:sp>
-      <p:sp>
-        <p:nvSpPr>
-          <p:cNvPr id="38" name="Shape 36"/>
-          <p:cNvSpPr/>
-          <p:nvPr/>
-        </p:nvSpPr>
-        <p:spPr>
-          <a:xfrm>
-            <a:off x="5067300" y="3589020"/>
-            <a:ext cx="6134100" cy="441960"/>
+          <p:cNvPr id="67" name="Text 65"/>
+          <p:cNvSpPr txBox="1"/>
+          <p:nvPr/>
+        </p:nvSpPr>
+        <p:spPr>
+          <a:xfrm>
+            <a:off x="7528560" y="4495800"/>
+            <a:ext cx="1661160" cy="167640"/>
+          </a:xfrm>
+          <a:prstGeom prst="rect">
+            <a:avLst/>
+          </a:prstGeom>
+          <a:noFill/>
+          <a:ln/>
+        </p:spPr>
+        <p:txBody>
+          <a:bodyPr wrap="square" lIns="0" tIns="0" rIns="0" bIns="0" rtlCol="0" anchor="ctr">
+            <a:normAutofit/>
+          </a:bodyPr>
+          <a:lstStyle/>
+          <a:p>
+            <a:pPr algn="l" indent="0" marL="0">
+              <a:buNone/>
+            </a:pPr>
+            <a:r>
+              <a:rPr lang="en-US" sz="660" b="1" dirty="0">
+                <a:solidFill>
+                  <a:srgbClr val="344258"/>
+                </a:solidFill>
+                <a:latin typeface="Aptos" pitchFamily="34" charset="0"/>
+                <a:ea typeface="Aptos" pitchFamily="34" charset="-122"/>
+                <a:cs typeface="Aptos" pitchFamily="34" charset="-120"/>
+              </a:rPr>
+              <a:t>Extract + challenge</a:t>
+            </a:r>
+            <a:endParaRPr lang="en-US" sz="660" dirty="0"/>
+          </a:p>
+        </p:txBody>
+      </p:sp>
+      <p:sp>
+        <p:nvSpPr>
+          <p:cNvPr id="68" name="Shape 66"/>
+          <p:cNvSpPr/>
+          <p:nvPr/>
+        </p:nvSpPr>
+        <p:spPr>
+          <a:xfrm>
+            <a:off x="9616440" y="4328160"/>
+            <a:ext cx="-274320" cy="0"/>
+          </a:xfrm>
+          <a:prstGeom prst="line">
+            <a:avLst/>
+          </a:prstGeom>
+          <a:noFill/>
+          <a:ln w="22860">
+            <a:solidFill>
+              <a:srgbClr val="B87932"/>
+            </a:solidFill>
+            <a:prstDash val="solid"/>
+            <a:headEnd type="none"/>
+            <a:tailEnd type="triangle"/>
+          </a:ln>
+        </p:spPr>
+      </p:sp>
+      <p:sp>
+        <p:nvSpPr>
+          <p:cNvPr id="69" name="Shape 67"/>
+          <p:cNvSpPr/>
+          <p:nvPr/>
+        </p:nvSpPr>
+        <p:spPr>
+          <a:xfrm>
+            <a:off x="9646920" y="3886200"/>
+            <a:ext cx="1905000" cy="883920"/>
           </a:xfrm>
           <a:prstGeom prst="roundRect">
             <a:avLst>
-              <a:gd name="adj" fmla="val 24828"/>
+              <a:gd name="adj" fmla="val 14483"/>
             </a:avLst>
           </a:prstGeom>
           <a:solidFill>
-            <a:srgbClr val="FFF1DF"/>
+            <a:srgbClr val="E4F2ED"/>
           </a:solidFill>
           <a:ln w="6350">
             <a:solidFill>
-              <a:srgbClr val="FFF1DF">
+              <a:srgbClr val="E4F2ED">
                 <a:alpha val="0"/>
               </a:srgbClr>
             </a:solidFill>
@@ -12483,18 +13504,18 @@
       </p:sp>
       <p:sp>
         <p:nvSpPr>
-          <p:cNvPr id="39" name="Shape 37"/>
-          <p:cNvSpPr/>
-          <p:nvPr/>
-        </p:nvSpPr>
-        <p:spPr>
-          <a:xfrm>
-            <a:off x="5181600" y="3680460"/>
-            <a:ext cx="365760" cy="259080"/>
+          <p:cNvPr id="70" name="Shape 68"/>
+          <p:cNvSpPr/>
+          <p:nvPr/>
+        </p:nvSpPr>
+        <p:spPr>
+          <a:xfrm>
+            <a:off x="9768840" y="4000500"/>
+            <a:ext cx="320040" cy="213360"/>
           </a:xfrm>
           <a:prstGeom prst="roundRect">
             <a:avLst>
-              <a:gd name="adj" fmla="val 56471"/>
+              <a:gd name="adj" fmla="val 68571"/>
             </a:avLst>
           </a:prstGeom>
           <a:solidFill>
@@ -12512,14 +13533,14 @@
       </p:sp>
       <p:sp>
         <p:nvSpPr>
-          <p:cNvPr id="40" name="Text 38"/>
-          <p:cNvSpPr txBox="1"/>
-          <p:nvPr/>
-        </p:nvSpPr>
-        <p:spPr>
-          <a:xfrm>
-            <a:off x="5257800" y="3703320"/>
-            <a:ext cx="213360" cy="213360"/>
+          <p:cNvPr id="71" name="Text 69"/>
+          <p:cNvSpPr txBox="1"/>
+          <p:nvPr/>
+        </p:nvSpPr>
+        <p:spPr>
+          <a:xfrm>
+            <a:off x="9845040" y="4023360"/>
+            <a:ext cx="167640" cy="167640"/>
           </a:xfrm>
           <a:prstGeom prst="rect">
             <a:avLst/>
@@ -12537,97 +13558,56 @@
               <a:buNone/>
             </a:pPr>
             <a:r>
-              <a:rPr lang="en-US" sz="600" b="1" spc="30" kern="0" dirty="0">
-                <a:solidFill>
-                  <a:srgbClr val="B87932"/>
-                </a:solidFill>
-                <a:latin typeface="Aptos" pitchFamily="34" charset="0"/>
-                <a:ea typeface="Aptos" pitchFamily="34" charset="-122"/>
-                <a:cs typeface="Aptos" pitchFamily="34" charset="-120"/>
-              </a:rPr>
-              <a:t>03</a:t>
-            </a:r>
-            <a:endParaRPr lang="en-US" sz="600" dirty="0"/>
-          </a:p>
-        </p:txBody>
-      </p:sp>
-      <p:sp>
-        <p:nvSpPr>
-          <p:cNvPr id="41" name="Text 39"/>
-          <p:cNvSpPr txBox="1"/>
-          <p:nvPr/>
-        </p:nvSpPr>
-        <p:spPr>
-          <a:xfrm>
-            <a:off x="5715000" y="3634740"/>
-            <a:ext cx="1905000" cy="182880"/>
-          </a:xfrm>
-          <a:prstGeom prst="rect">
-            <a:avLst/>
-          </a:prstGeom>
-          <a:noFill/>
-          <a:ln/>
-        </p:spPr>
-        <p:txBody>
-          <a:bodyPr wrap="square" lIns="0" tIns="0" rIns="0" bIns="0" rtlCol="0" anchor="ctr">
-            <a:normAutofit/>
-          </a:bodyPr>
-          <a:lstStyle/>
-          <a:p>
-            <a:pPr algn="l" indent="0" marL="0">
-              <a:buNone/>
-            </a:pPr>
-            <a:r>
-              <a:rPr lang="en-US" sz="960" b="1" dirty="0">
-                <a:solidFill>
-                  <a:srgbClr val="172337"/>
-                </a:solidFill>
-                <a:latin typeface="Aptos" pitchFamily="34" charset="0"/>
-                <a:ea typeface="Aptos" pitchFamily="34" charset="-122"/>
-                <a:cs typeface="Aptos" pitchFamily="34" charset="-120"/>
-              </a:rPr>
-              <a:t>Redis → ARQ worker</a:t>
-            </a:r>
-            <a:endParaRPr lang="en-US" sz="960" dirty="0"/>
-          </a:p>
-        </p:txBody>
-      </p:sp>
-      <p:sp>
-        <p:nvSpPr>
-          <p:cNvPr id="42" name="Text 40"/>
-          <p:cNvSpPr txBox="1"/>
-          <p:nvPr/>
-        </p:nvSpPr>
-        <p:spPr>
-          <a:xfrm>
-            <a:off x="7658100" y="3649980"/>
-            <a:ext cx="3276600" cy="182880"/>
-          </a:xfrm>
-          <a:prstGeom prst="rect">
-            <a:avLst/>
-          </a:prstGeom>
-          <a:noFill/>
-          <a:ln/>
-        </p:spPr>
-        <p:txBody>
-          <a:bodyPr wrap="square" lIns="0" tIns="0" rIns="0" bIns="0" rtlCol="0" anchor="ctr">
-            <a:normAutofit/>
-          </a:bodyPr>
-          <a:lstStyle/>
-          <a:p>
-            <a:pPr algn="r" indent="0" marL="0">
-              <a:buNone/>
-            </a:pPr>
-            <a:r>
-              <a:rPr lang="en-US" sz="780" dirty="0">
-                <a:solidFill>
-                  <a:srgbClr val="718097"/>
-                </a:solidFill>
-                <a:latin typeface="Aptos" pitchFamily="34" charset="0"/>
-                <a:ea typeface="Aptos" pitchFamily="34" charset="-122"/>
-                <a:cs typeface="Aptos" pitchFamily="34" charset="-120"/>
-              </a:rPr>
-              <a:t>Deadline-aware collection jobs</a:t>
+              <a:rPr lang="en-US" sz="540" b="1" spc="30" kern="0" dirty="0">
+                <a:solidFill>
+                  <a:srgbClr val="2F8B72"/>
+                </a:solidFill>
+                <a:latin typeface="Aptos" pitchFamily="34" charset="0"/>
+                <a:ea typeface="Aptos" pitchFamily="34" charset="-122"/>
+                <a:cs typeface="Aptos" pitchFamily="34" charset="-120"/>
+              </a:rPr>
+              <a:t>07</a:t>
+            </a:r>
+            <a:endParaRPr lang="en-US" sz="540" dirty="0"/>
+          </a:p>
+        </p:txBody>
+      </p:sp>
+      <p:sp>
+        <p:nvSpPr>
+          <p:cNvPr id="72" name="Text 70"/>
+          <p:cNvSpPr txBox="1"/>
+          <p:nvPr/>
+        </p:nvSpPr>
+        <p:spPr>
+          <a:xfrm>
+            <a:off x="9768840" y="4274820"/>
+            <a:ext cx="1661160" cy="175260"/>
+          </a:xfrm>
+          <a:prstGeom prst="rect">
+            <a:avLst/>
+          </a:prstGeom>
+          <a:noFill/>
+          <a:ln/>
+        </p:spPr>
+        <p:txBody>
+          <a:bodyPr wrap="square" lIns="0" tIns="0" rIns="0" bIns="0" rtlCol="0" anchor="ctr">
+            <a:normAutofit/>
+          </a:bodyPr>
+          <a:lstStyle/>
+          <a:p>
+            <a:pPr algn="l" indent="0" marL="0">
+              <a:buNone/>
+            </a:pPr>
+            <a:r>
+              <a:rPr lang="en-US" sz="780" b="1" spc="70" kern="0" dirty="0">
+                <a:solidFill>
+                  <a:srgbClr val="2F8B72"/>
+                </a:solidFill>
+                <a:latin typeface="Aptos" pitchFamily="34" charset="0"/>
+                <a:ea typeface="Aptos" pitchFamily="34" charset="-122"/>
+                <a:cs typeface="Aptos" pitchFamily="34" charset="-120"/>
+              </a:rPr>
+              <a:t>INBOUND</a:t>
             </a:r>
             <a:endParaRPr lang="en-US" sz="780" dirty="0"/>
           </a:p>
@@ -12635,55 +13615,55 @@
       </p:sp>
       <p:sp>
         <p:nvSpPr>
-          <p:cNvPr id="43" name="Text 41"/>
-          <p:cNvSpPr txBox="1"/>
-          <p:nvPr/>
-        </p:nvSpPr>
-        <p:spPr>
-          <a:xfrm>
-            <a:off x="8077200" y="4015740"/>
-            <a:ext cx="304800" cy="182880"/>
-          </a:xfrm>
-          <a:prstGeom prst="rect">
-            <a:avLst/>
-          </a:prstGeom>
-          <a:noFill/>
-          <a:ln/>
-        </p:spPr>
-        <p:txBody>
-          <a:bodyPr wrap="square" lIns="0" tIns="0" rIns="0" bIns="0" rtlCol="0" anchor="ctr">
-            <a:normAutofit/>
-          </a:bodyPr>
-          <a:lstStyle/>
-          <a:p>
-            <a:pPr algn="ctr" indent="0" marL="0">
-              <a:buNone/>
-            </a:pPr>
-            <a:r>
-              <a:rPr lang="en-US" sz="960" b="1" dirty="0">
-                <a:solidFill>
-                  <a:srgbClr val="B87932"/>
-                </a:solidFill>
-                <a:latin typeface="Aptos" pitchFamily="34" charset="0"/>
-                <a:ea typeface="Aptos" pitchFamily="34" charset="-122"/>
-                <a:cs typeface="Aptos" pitchFamily="34" charset="-120"/>
-              </a:rPr>
-              <a:t>↓</a:t>
-            </a:r>
-            <a:endParaRPr lang="en-US" sz="960" dirty="0"/>
-          </a:p>
-        </p:txBody>
-      </p:sp>
-      <p:sp>
-        <p:nvSpPr>
-          <p:cNvPr id="44" name="Shape 42"/>
-          <p:cNvSpPr/>
-          <p:nvPr/>
-        </p:nvSpPr>
-        <p:spPr>
-          <a:xfrm>
-            <a:off x="5067300" y="4183380"/>
-            <a:ext cx="6134100" cy="441960"/>
+          <p:cNvPr id="73" name="Text 71"/>
+          <p:cNvSpPr txBox="1"/>
+          <p:nvPr/>
+        </p:nvSpPr>
+        <p:spPr>
+          <a:xfrm>
+            <a:off x="9768840" y="4495800"/>
+            <a:ext cx="1661160" cy="167640"/>
+          </a:xfrm>
+          <a:prstGeom prst="rect">
+            <a:avLst/>
+          </a:prstGeom>
+          <a:noFill/>
+          <a:ln/>
+        </p:spPr>
+        <p:txBody>
+          <a:bodyPr wrap="square" lIns="0" tIns="0" rIns="0" bIns="0" rtlCol="0" anchor="ctr">
+            <a:normAutofit/>
+          </a:bodyPr>
+          <a:lstStyle/>
+          <a:p>
+            <a:pPr algn="l" indent="0" marL="0">
+              <a:buNone/>
+            </a:pPr>
+            <a:r>
+              <a:rPr lang="en-US" sz="660" b="1" dirty="0">
+                <a:solidFill>
+                  <a:srgbClr val="344258"/>
+                </a:solidFill>
+                <a:latin typeface="Aptos" pitchFamily="34" charset="0"/>
+                <a:ea typeface="Aptos" pitchFamily="34" charset="-122"/>
+                <a:cs typeface="Aptos" pitchFamily="34" charset="-120"/>
+              </a:rPr>
+              <a:t>Application + pitch deck</a:t>
+            </a:r>
+            <a:endParaRPr lang="en-US" sz="660" dirty="0"/>
+          </a:p>
+        </p:txBody>
+      </p:sp>
+      <p:sp>
+        <p:nvSpPr>
+          <p:cNvPr id="74" name="Shape 72"/>
+          <p:cNvSpPr/>
+          <p:nvPr/>
+        </p:nvSpPr>
+        <p:spPr>
+          <a:xfrm>
+            <a:off x="685800" y="5059680"/>
+            <a:ext cx="11201400" cy="441960"/>
           </a:xfrm>
           <a:prstGeom prst="roundRect">
             <a:avLst>
@@ -12691,11 +13671,11 @@
             </a:avLst>
           </a:prstGeom>
           <a:solidFill>
-            <a:srgbClr val="E4F2ED"/>
+            <a:srgbClr val="E9F0F8"/>
           </a:solidFill>
           <a:ln w="6350">
             <a:solidFill>
-              <a:srgbClr val="E4F2ED">
+              <a:srgbClr val="E9F0F8">
                 <a:alpha val="0"/>
               </a:srgbClr>
             </a:solidFill>
@@ -12705,18 +13685,223 @@
       </p:sp>
       <p:sp>
         <p:nvSpPr>
-          <p:cNvPr id="45" name="Shape 43"/>
-          <p:cNvSpPr/>
-          <p:nvPr/>
-        </p:nvSpPr>
-        <p:spPr>
-          <a:xfrm>
-            <a:off x="5181600" y="4274820"/>
-            <a:ext cx="365760" cy="259080"/>
+          <p:cNvPr id="75" name="Text 73"/>
+          <p:cNvSpPr txBox="1"/>
+          <p:nvPr/>
+        </p:nvSpPr>
+        <p:spPr>
+          <a:xfrm>
+            <a:off x="876300" y="5166360"/>
+            <a:ext cx="2590800" cy="190500"/>
+          </a:xfrm>
+          <a:prstGeom prst="rect">
+            <a:avLst/>
+          </a:prstGeom>
+          <a:noFill/>
+          <a:ln/>
+        </p:spPr>
+        <p:txBody>
+          <a:bodyPr wrap="square" lIns="0" tIns="0" rIns="0" bIns="0" rtlCol="0" anchor="ctr">
+            <a:normAutofit/>
+          </a:bodyPr>
+          <a:lstStyle/>
+          <a:p>
+            <a:pPr algn="l" indent="0" marL="0">
+              <a:buNone/>
+            </a:pPr>
+            <a:r>
+              <a:rPr lang="en-US" sz="720" b="1" spc="80" kern="0" dirty="0">
+                <a:solidFill>
+                  <a:srgbClr val="344258"/>
+                </a:solidFill>
+                <a:latin typeface="Aptos" pitchFamily="34" charset="0"/>
+                <a:ea typeface="Aptos" pitchFamily="34" charset="-122"/>
+                <a:cs typeface="Aptos" pitchFamily="34" charset="-120"/>
+              </a:rPr>
+              <a:t>HUMAN DECISIONS + OUTCOMES</a:t>
+            </a:r>
+            <a:endParaRPr lang="en-US" sz="720" dirty="0"/>
+          </a:p>
+        </p:txBody>
+      </p:sp>
+      <p:sp>
+        <p:nvSpPr>
+          <p:cNvPr id="76" name="Text 74"/>
+          <p:cNvSpPr txBox="1"/>
+          <p:nvPr/>
+        </p:nvSpPr>
+        <p:spPr>
+          <a:xfrm>
+            <a:off x="3467100" y="5143500"/>
+            <a:ext cx="342900" cy="190500"/>
+          </a:xfrm>
+          <a:prstGeom prst="rect">
+            <a:avLst/>
+          </a:prstGeom>
+          <a:noFill/>
+          <a:ln/>
+        </p:spPr>
+        <p:txBody>
+          <a:bodyPr wrap="square" lIns="0" tIns="0" rIns="0" bIns="0" rtlCol="0" anchor="ctr">
+            <a:normAutofit/>
+          </a:bodyPr>
+          <a:lstStyle/>
+          <a:p>
+            <a:pPr algn="ctr" indent="0" marL="0">
+              <a:buNone/>
+            </a:pPr>
+            <a:r>
+              <a:rPr lang="en-US" sz="1080" b="1" dirty="0">
+                <a:solidFill>
+                  <a:srgbClr val="557DC0"/>
+                </a:solidFill>
+                <a:latin typeface="Aptos" pitchFamily="34" charset="0"/>
+                <a:ea typeface="Aptos" pitchFamily="34" charset="-122"/>
+                <a:cs typeface="Aptos" pitchFamily="34" charset="-120"/>
+              </a:rPr>
+              <a:t>→</a:t>
+            </a:r>
+            <a:endParaRPr lang="en-US" sz="1080" dirty="0"/>
+          </a:p>
+        </p:txBody>
+      </p:sp>
+      <p:sp>
+        <p:nvSpPr>
+          <p:cNvPr id="77" name="Text 75"/>
+          <p:cNvSpPr txBox="1"/>
+          <p:nvPr/>
+        </p:nvSpPr>
+        <p:spPr>
+          <a:xfrm>
+            <a:off x="3886200" y="5166360"/>
+            <a:ext cx="914400" cy="190500"/>
+          </a:xfrm>
+          <a:prstGeom prst="rect">
+            <a:avLst/>
+          </a:prstGeom>
+          <a:noFill/>
+          <a:ln/>
+        </p:spPr>
+        <p:txBody>
+          <a:bodyPr wrap="square" lIns="0" tIns="0" rIns="0" bIns="0" rtlCol="0" anchor="ctr">
+            <a:normAutofit/>
+          </a:bodyPr>
+          <a:lstStyle/>
+          <a:p>
+            <a:pPr algn="l" indent="0" marL="0">
+              <a:buNone/>
+            </a:pPr>
+            <a:r>
+              <a:rPr lang="en-US" sz="720" b="1" spc="120" kern="0" dirty="0">
+                <a:solidFill>
+                  <a:srgbClr val="557DC0"/>
+                </a:solidFill>
+                <a:latin typeface="Aptos" pitchFamily="34" charset="0"/>
+                <a:ea typeface="Aptos" pitchFamily="34" charset="-122"/>
+                <a:cs typeface="Aptos" pitchFamily="34" charset="-120"/>
+              </a:rPr>
+              <a:t>MEMORY</a:t>
+            </a:r>
+            <a:endParaRPr lang="en-US" sz="720" dirty="0"/>
+          </a:p>
+        </p:txBody>
+      </p:sp>
+      <p:sp>
+        <p:nvSpPr>
+          <p:cNvPr id="78" name="Text 76"/>
+          <p:cNvSpPr txBox="1"/>
+          <p:nvPr/>
+        </p:nvSpPr>
+        <p:spPr>
+          <a:xfrm>
+            <a:off x="4876800" y="5143500"/>
+            <a:ext cx="342900" cy="190500"/>
+          </a:xfrm>
+          <a:prstGeom prst="rect">
+            <a:avLst/>
+          </a:prstGeom>
+          <a:noFill/>
+          <a:ln/>
+        </p:spPr>
+        <p:txBody>
+          <a:bodyPr wrap="square" lIns="0" tIns="0" rIns="0" bIns="0" rtlCol="0" anchor="ctr">
+            <a:normAutofit/>
+          </a:bodyPr>
+          <a:lstStyle/>
+          <a:p>
+            <a:pPr algn="ctr" indent="0" marL="0">
+              <a:buNone/>
+            </a:pPr>
+            <a:r>
+              <a:rPr lang="en-US" sz="1080" b="1" dirty="0">
+                <a:solidFill>
+                  <a:srgbClr val="557DC0"/>
+                </a:solidFill>
+                <a:latin typeface="Aptos" pitchFamily="34" charset="0"/>
+                <a:ea typeface="Aptos" pitchFamily="34" charset="-122"/>
+                <a:cs typeface="Aptos" pitchFamily="34" charset="-120"/>
+              </a:rPr>
+              <a:t>→</a:t>
+            </a:r>
+            <a:endParaRPr lang="en-US" sz="1080" dirty="0"/>
+          </a:p>
+        </p:txBody>
+      </p:sp>
+      <p:sp>
+        <p:nvSpPr>
+          <p:cNvPr id="79" name="Text 77"/>
+          <p:cNvSpPr txBox="1"/>
+          <p:nvPr/>
+        </p:nvSpPr>
+        <p:spPr>
+          <a:xfrm>
+            <a:off x="5295900" y="5166360"/>
+            <a:ext cx="3276600" cy="190500"/>
+          </a:xfrm>
+          <a:prstGeom prst="rect">
+            <a:avLst/>
+          </a:prstGeom>
+          <a:noFill/>
+          <a:ln/>
+        </p:spPr>
+        <p:txBody>
+          <a:bodyPr wrap="square" lIns="0" tIns="0" rIns="0" bIns="0" rtlCol="0" anchor="ctr">
+            <a:normAutofit/>
+          </a:bodyPr>
+          <a:lstStyle/>
+          <a:p>
+            <a:pPr algn="l" indent="0" marL="0">
+              <a:buNone/>
+            </a:pPr>
+            <a:r>
+              <a:rPr lang="en-US" sz="720" b="1" spc="80" kern="0" dirty="0">
+                <a:solidFill>
+                  <a:srgbClr val="344258"/>
+                </a:solidFill>
+                <a:latin typeface="Aptos" pitchFamily="34" charset="0"/>
+                <a:ea typeface="Aptos" pitchFamily="34" charset="-122"/>
+                <a:cs typeface="Aptos" pitchFamily="34" charset="-120"/>
+              </a:rPr>
+              <a:t>SHARPER THESIS + FUTURE SCORING</a:t>
+            </a:r>
+            <a:endParaRPr lang="en-US" sz="720" dirty="0"/>
+          </a:p>
+        </p:txBody>
+      </p:sp>
+      <p:sp>
+        <p:nvSpPr>
+          <p:cNvPr id="80" name="Shape 78"/>
+          <p:cNvSpPr/>
+          <p:nvPr/>
+        </p:nvSpPr>
+        <p:spPr>
+          <a:xfrm>
+            <a:off x="685800" y="5692140"/>
+            <a:ext cx="1485900" cy="266700"/>
           </a:xfrm>
           <a:prstGeom prst="roundRect">
             <a:avLst>
-              <a:gd name="adj" fmla="val 56471"/>
+              <a:gd name="adj" fmla="val 54857"/>
             </a:avLst>
           </a:prstGeom>
           <a:solidFill>
@@ -12734,14 +13919,14 @@
       </p:sp>
       <p:sp>
         <p:nvSpPr>
-          <p:cNvPr id="46" name="Text 44"/>
-          <p:cNvSpPr txBox="1"/>
-          <p:nvPr/>
-        </p:nvSpPr>
-        <p:spPr>
-          <a:xfrm>
-            <a:off x="5257800" y="4297680"/>
-            <a:ext cx="213360" cy="213360"/>
+          <p:cNvPr id="81" name="Text 79"/>
+          <p:cNvSpPr txBox="1"/>
+          <p:nvPr/>
+        </p:nvSpPr>
+        <p:spPr>
+          <a:xfrm>
+            <a:off x="762000" y="5715000"/>
+            <a:ext cx="1333500" cy="220980"/>
           </a:xfrm>
           <a:prstGeom prst="rect">
             <a:avLst/>
@@ -12759,7 +13944,217 @@
               <a:buNone/>
             </a:pPr>
             <a:r>
-              <a:rPr lang="en-US" sz="600" b="1" spc="30" kern="0" dirty="0">
+              <a:rPr lang="en-US" sz="540" b="1" spc="30" kern="0" dirty="0">
+                <a:solidFill>
+                  <a:srgbClr val="557DC0"/>
+                </a:solidFill>
+                <a:latin typeface="Aptos" pitchFamily="34" charset="0"/>
+                <a:ea typeface="Aptos" pitchFamily="34" charset="-122"/>
+                <a:cs typeface="Aptos" pitchFamily="34" charset="-120"/>
+              </a:rPr>
+              <a:t>React + TypeScript</a:t>
+            </a:r>
+            <a:endParaRPr lang="en-US" sz="540" dirty="0"/>
+          </a:p>
+        </p:txBody>
+      </p:sp>
+      <p:sp>
+        <p:nvSpPr>
+          <p:cNvPr id="82" name="Shape 80"/>
+          <p:cNvSpPr/>
+          <p:nvPr/>
+        </p:nvSpPr>
+        <p:spPr>
+          <a:xfrm>
+            <a:off x="2286000" y="5692140"/>
+            <a:ext cx="952500" cy="266700"/>
+          </a:xfrm>
+          <a:prstGeom prst="roundRect">
+            <a:avLst>
+              <a:gd name="adj" fmla="val 54857"/>
+            </a:avLst>
+          </a:prstGeom>
+          <a:solidFill>
+            <a:srgbClr val="FFFFFF"/>
+          </a:solidFill>
+          <a:ln w="6350">
+            <a:solidFill>
+              <a:srgbClr val="FFFFFF">
+                <a:alpha val="0"/>
+              </a:srgbClr>
+            </a:solidFill>
+            <a:prstDash val="solid"/>
+          </a:ln>
+        </p:spPr>
+      </p:sp>
+      <p:sp>
+        <p:nvSpPr>
+          <p:cNvPr id="83" name="Text 81"/>
+          <p:cNvSpPr txBox="1"/>
+          <p:nvPr/>
+        </p:nvSpPr>
+        <p:spPr>
+          <a:xfrm>
+            <a:off x="2362200" y="5715000"/>
+            <a:ext cx="800100" cy="220980"/>
+          </a:xfrm>
+          <a:prstGeom prst="rect">
+            <a:avLst/>
+          </a:prstGeom>
+          <a:noFill/>
+          <a:ln/>
+        </p:spPr>
+        <p:txBody>
+          <a:bodyPr wrap="square" lIns="0" tIns="0" rIns="0" bIns="0" rtlCol="0" anchor="ctr">
+            <a:normAutofit/>
+          </a:bodyPr>
+          <a:lstStyle/>
+          <a:p>
+            <a:pPr algn="ctr" indent="0" marL="0">
+              <a:buNone/>
+            </a:pPr>
+            <a:r>
+              <a:rPr lang="en-US" sz="540" b="1" spc="30" kern="0" dirty="0">
+                <a:solidFill>
+                  <a:srgbClr val="7656A5"/>
+                </a:solidFill>
+                <a:latin typeface="Aptos" pitchFamily="34" charset="0"/>
+                <a:ea typeface="Aptos" pitchFamily="34" charset="-122"/>
+                <a:cs typeface="Aptos" pitchFamily="34" charset="-120"/>
+              </a:rPr>
+              <a:t>FastAPI</a:t>
+            </a:r>
+            <a:endParaRPr lang="en-US" sz="540" dirty="0"/>
+          </a:p>
+        </p:txBody>
+      </p:sp>
+      <p:sp>
+        <p:nvSpPr>
+          <p:cNvPr id="84" name="Shape 82"/>
+          <p:cNvSpPr/>
+          <p:nvPr/>
+        </p:nvSpPr>
+        <p:spPr>
+          <a:xfrm>
+            <a:off x="3352800" y="5692140"/>
+            <a:ext cx="1104900" cy="266700"/>
+          </a:xfrm>
+          <a:prstGeom prst="roundRect">
+            <a:avLst>
+              <a:gd name="adj" fmla="val 54857"/>
+            </a:avLst>
+          </a:prstGeom>
+          <a:solidFill>
+            <a:srgbClr val="FFFFFF"/>
+          </a:solidFill>
+          <a:ln w="6350">
+            <a:solidFill>
+              <a:srgbClr val="FFFFFF">
+                <a:alpha val="0"/>
+              </a:srgbClr>
+            </a:solidFill>
+            <a:prstDash val="solid"/>
+          </a:ln>
+        </p:spPr>
+      </p:sp>
+      <p:sp>
+        <p:nvSpPr>
+          <p:cNvPr id="85" name="Text 83"/>
+          <p:cNvSpPr txBox="1"/>
+          <p:nvPr/>
+        </p:nvSpPr>
+        <p:spPr>
+          <a:xfrm>
+            <a:off x="3429000" y="5715000"/>
+            <a:ext cx="952500" cy="220980"/>
+          </a:xfrm>
+          <a:prstGeom prst="rect">
+            <a:avLst/>
+          </a:prstGeom>
+          <a:noFill/>
+          <a:ln/>
+        </p:spPr>
+        <p:txBody>
+          <a:bodyPr wrap="square" lIns="0" tIns="0" rIns="0" bIns="0" rtlCol="0" anchor="ctr">
+            <a:normAutofit/>
+          </a:bodyPr>
+          <a:lstStyle/>
+          <a:p>
+            <a:pPr algn="ctr" indent="0" marL="0">
+              <a:buNone/>
+            </a:pPr>
+            <a:r>
+              <a:rPr lang="en-US" sz="540" b="1" spc="30" kern="0" dirty="0">
+                <a:solidFill>
+                  <a:srgbClr val="B87932"/>
+                </a:solidFill>
+                <a:latin typeface="Aptos" pitchFamily="34" charset="0"/>
+                <a:ea typeface="Aptos" pitchFamily="34" charset="-122"/>
+                <a:cs typeface="Aptos" pitchFamily="34" charset="-120"/>
+              </a:rPr>
+              <a:t>ARQ + Redis</a:t>
+            </a:r>
+            <a:endParaRPr lang="en-US" sz="540" dirty="0"/>
+          </a:p>
+        </p:txBody>
+      </p:sp>
+      <p:sp>
+        <p:nvSpPr>
+          <p:cNvPr id="86" name="Shape 84"/>
+          <p:cNvSpPr/>
+          <p:nvPr/>
+        </p:nvSpPr>
+        <p:spPr>
+          <a:xfrm>
+            <a:off x="4572000" y="5692140"/>
+            <a:ext cx="1638300" cy="266700"/>
+          </a:xfrm>
+          <a:prstGeom prst="roundRect">
+            <a:avLst>
+              <a:gd name="adj" fmla="val 54857"/>
+            </a:avLst>
+          </a:prstGeom>
+          <a:solidFill>
+            <a:srgbClr val="FFFFFF"/>
+          </a:solidFill>
+          <a:ln w="6350">
+            <a:solidFill>
+              <a:srgbClr val="FFFFFF">
+                <a:alpha val="0"/>
+              </a:srgbClr>
+            </a:solidFill>
+            <a:prstDash val="solid"/>
+          </a:ln>
+        </p:spPr>
+      </p:sp>
+      <p:sp>
+        <p:nvSpPr>
+          <p:cNvPr id="87" name="Text 85"/>
+          <p:cNvSpPr txBox="1"/>
+          <p:nvPr/>
+        </p:nvSpPr>
+        <p:spPr>
+          <a:xfrm>
+            <a:off x="4648200" y="5715000"/>
+            <a:ext cx="1485900" cy="220980"/>
+          </a:xfrm>
+          <a:prstGeom prst="rect">
+            <a:avLst/>
+          </a:prstGeom>
+          <a:noFill/>
+          <a:ln/>
+        </p:spPr>
+        <p:txBody>
+          <a:bodyPr wrap="square" lIns="0" tIns="0" rIns="0" bIns="0" rtlCol="0" anchor="ctr">
+            <a:normAutofit/>
+          </a:bodyPr>
+          <a:lstStyle/>
+          <a:p>
+            <a:pPr algn="ctr" indent="0" marL="0">
+              <a:buNone/>
+            </a:pPr>
+            <a:r>
+              <a:rPr lang="en-US" sz="540" b="1" spc="30" kern="0" dirty="0">
                 <a:solidFill>
                   <a:srgbClr val="2F8B72"/>
                 </a:solidFill>
@@ -12767,145 +14162,92 @@
                 <a:ea typeface="Aptos" pitchFamily="34" charset="-122"/>
                 <a:cs typeface="Aptos" pitchFamily="34" charset="-120"/>
               </a:rPr>
-              <a:t>04</a:t>
-            </a:r>
-            <a:endParaRPr lang="en-US" sz="600" dirty="0"/>
-          </a:p>
-        </p:txBody>
-      </p:sp>
-      <p:sp>
-        <p:nvSpPr>
-          <p:cNvPr id="47" name="Text 45"/>
-          <p:cNvSpPr txBox="1"/>
-          <p:nvPr/>
-        </p:nvSpPr>
-        <p:spPr>
-          <a:xfrm>
-            <a:off x="5715000" y="4229100"/>
-            <a:ext cx="1905000" cy="182880"/>
-          </a:xfrm>
-          <a:prstGeom prst="rect">
-            <a:avLst/>
-          </a:prstGeom>
-          <a:noFill/>
-          <a:ln/>
-        </p:spPr>
-        <p:txBody>
-          <a:bodyPr wrap="square" lIns="0" tIns="0" rIns="0" bIns="0" rtlCol="0" anchor="ctr">
-            <a:normAutofit/>
-          </a:bodyPr>
-          <a:lstStyle/>
-          <a:p>
-            <a:pPr algn="l" indent="0" marL="0">
-              <a:buNone/>
-            </a:pPr>
-            <a:r>
-              <a:rPr lang="en-US" sz="960" b="1" dirty="0">
-                <a:solidFill>
-                  <a:srgbClr val="172337"/>
-                </a:solidFill>
-                <a:latin typeface="Aptos" pitchFamily="34" charset="0"/>
-                <a:ea typeface="Aptos" pitchFamily="34" charset="-122"/>
-                <a:cs typeface="Aptos" pitchFamily="34" charset="-120"/>
-              </a:rPr>
-              <a:t>Data plane</a:t>
-            </a:r>
-            <a:endParaRPr lang="en-US" sz="960" dirty="0"/>
-          </a:p>
-        </p:txBody>
-      </p:sp>
-      <p:sp>
-        <p:nvSpPr>
-          <p:cNvPr id="48" name="Text 46"/>
-          <p:cNvSpPr txBox="1"/>
-          <p:nvPr/>
-        </p:nvSpPr>
-        <p:spPr>
-          <a:xfrm>
-            <a:off x="7658100" y="4244340"/>
-            <a:ext cx="3276600" cy="182880"/>
-          </a:xfrm>
-          <a:prstGeom prst="rect">
-            <a:avLst/>
-          </a:prstGeom>
-          <a:noFill/>
-          <a:ln/>
-        </p:spPr>
-        <p:txBody>
-          <a:bodyPr wrap="square" lIns="0" tIns="0" rIns="0" bIns="0" rtlCol="0" anchor="ctr">
-            <a:normAutofit/>
-          </a:bodyPr>
-          <a:lstStyle/>
-          <a:p>
-            <a:pPr algn="r" indent="0" marL="0">
-              <a:buNone/>
-            </a:pPr>
-            <a:r>
-              <a:rPr lang="en-US" sz="780" dirty="0">
-                <a:solidFill>
-                  <a:srgbClr val="718097"/>
-                </a:solidFill>
-                <a:latin typeface="Aptos" pitchFamily="34" charset="0"/>
-                <a:ea typeface="Aptos" pitchFamily="34" charset="-122"/>
-                <a:cs typeface="Aptos" pitchFamily="34" charset="-120"/>
-              </a:rPr>
-              <a:t>Postgres/pgvector + immutable MinIO</a:t>
-            </a:r>
-            <a:endParaRPr lang="en-US" sz="780" dirty="0"/>
-          </a:p>
-        </p:txBody>
-      </p:sp>
-      <p:sp>
-        <p:nvSpPr>
-          <p:cNvPr id="49" name="Text 47"/>
-          <p:cNvSpPr txBox="1"/>
-          <p:nvPr/>
-        </p:nvSpPr>
-        <p:spPr>
-          <a:xfrm>
-            <a:off x="5067300" y="4914900"/>
-            <a:ext cx="2895600" cy="198120"/>
-          </a:xfrm>
-          <a:prstGeom prst="rect">
-            <a:avLst/>
-          </a:prstGeom>
-          <a:noFill/>
-          <a:ln/>
-        </p:spPr>
-        <p:txBody>
-          <a:bodyPr wrap="square" lIns="0" tIns="0" rIns="0" bIns="0" rtlCol="0" anchor="ctr">
-            <a:normAutofit/>
-          </a:bodyPr>
-          <a:lstStyle/>
-          <a:p>
-            <a:pPr algn="l" indent="0" marL="0">
-              <a:buNone/>
-            </a:pPr>
-            <a:r>
-              <a:rPr lang="en-US" sz="720" b="1" spc="160" kern="0" dirty="0">
-                <a:solidFill>
-                  <a:srgbClr val="557DC0"/>
-                </a:solidFill>
-                <a:latin typeface="Aptos" pitchFamily="34" charset="0"/>
-                <a:ea typeface="Aptos" pitchFamily="34" charset="-122"/>
-                <a:cs typeface="Aptos" pitchFamily="34" charset="-120"/>
-              </a:rPr>
-              <a:t>IMPLEMENTATION PRINCIPLES</a:t>
-            </a:r>
-            <a:endParaRPr lang="en-US" sz="720" dirty="0"/>
-          </a:p>
-        </p:txBody>
-      </p:sp>
-      <p:sp>
-        <p:nvSpPr>
-          <p:cNvPr id="50" name="Shape 48"/>
-          <p:cNvSpPr/>
-          <p:nvPr/>
-        </p:nvSpPr>
-        <p:spPr>
-          <a:xfrm>
-            <a:off x="5067300" y="5257800"/>
+              <a:t>Postgres + pgvector</a:t>
+            </a:r>
+            <a:endParaRPr lang="en-US" sz="540" dirty="0"/>
+          </a:p>
+        </p:txBody>
+      </p:sp>
+      <p:sp>
+        <p:nvSpPr>
+          <p:cNvPr id="88" name="Shape 86"/>
+          <p:cNvSpPr/>
+          <p:nvPr/>
+        </p:nvSpPr>
+        <p:spPr>
+          <a:xfrm>
+            <a:off x="6324600" y="5692140"/>
             <a:ext cx="1371600" cy="266700"/>
+          </a:xfrm>
+          <a:prstGeom prst="roundRect">
+            <a:avLst>
+              <a:gd name="adj" fmla="val 54857"/>
+            </a:avLst>
+          </a:prstGeom>
+          <a:solidFill>
+            <a:srgbClr val="FFFFFF"/>
+          </a:solidFill>
+          <a:ln w="6350">
+            <a:solidFill>
+              <a:srgbClr val="FFFFFF">
+                <a:alpha val="0"/>
+              </a:srgbClr>
+            </a:solidFill>
+            <a:prstDash val="solid"/>
+          </a:ln>
+        </p:spPr>
+      </p:sp>
+      <p:sp>
+        <p:nvSpPr>
+          <p:cNvPr id="89" name="Text 87"/>
+          <p:cNvSpPr txBox="1"/>
+          <p:nvPr/>
+        </p:nvSpPr>
+        <p:spPr>
+          <a:xfrm>
+            <a:off x="6400800" y="5715000"/>
+            <a:ext cx="1219200" cy="220980"/>
+          </a:xfrm>
+          <a:prstGeom prst="rect">
+            <a:avLst/>
+          </a:prstGeom>
+          <a:noFill/>
+          <a:ln/>
+        </p:spPr>
+        <p:txBody>
+          <a:bodyPr wrap="square" lIns="0" tIns="0" rIns="0" bIns="0" rtlCol="0" anchor="ctr">
+            <a:normAutofit/>
+          </a:bodyPr>
+          <a:lstStyle/>
+          <a:p>
+            <a:pPr algn="ctr" indent="0" marL="0">
+              <a:buNone/>
+            </a:pPr>
+            <a:r>
+              <a:rPr lang="en-US" sz="540" b="1" spc="30" kern="0" dirty="0">
+                <a:solidFill>
+                  <a:srgbClr val="344258"/>
+                </a:solidFill>
+                <a:latin typeface="Aptos" pitchFamily="34" charset="0"/>
+                <a:ea typeface="Aptos" pitchFamily="34" charset="-122"/>
+                <a:cs typeface="Aptos" pitchFamily="34" charset="-120"/>
+              </a:rPr>
+              <a:t>MinIO + Docker</a:t>
+            </a:r>
+            <a:endParaRPr lang="en-US" sz="540" dirty="0"/>
+          </a:p>
+        </p:txBody>
+      </p:sp>
+      <p:sp>
+        <p:nvSpPr>
+          <p:cNvPr id="90" name="Shape 88"/>
+          <p:cNvSpPr/>
+          <p:nvPr/>
+        </p:nvSpPr>
+        <p:spPr>
+          <a:xfrm>
+            <a:off x="8839200" y="5692140"/>
+            <a:ext cx="1905000" cy="266700"/>
           </a:xfrm>
           <a:prstGeom prst="roundRect">
             <a:avLst>
@@ -12927,14 +14269,14 @@
       </p:sp>
       <p:sp>
         <p:nvSpPr>
-          <p:cNvPr id="51" name="Text 49"/>
-          <p:cNvSpPr txBox="1"/>
-          <p:nvPr/>
-        </p:nvSpPr>
-        <p:spPr>
-          <a:xfrm>
-            <a:off x="5143500" y="5280660"/>
-            <a:ext cx="1219200" cy="220980"/>
+          <p:cNvPr id="91" name="Text 89"/>
+          <p:cNvSpPr txBox="1"/>
+          <p:nvPr/>
+        </p:nvSpPr>
+        <p:spPr>
+          <a:xfrm>
+            <a:off x="8915400" y="5715000"/>
+            <a:ext cx="1752600" cy="220980"/>
           </a:xfrm>
           <a:prstGeom prst="rect">
             <a:avLst/>
@@ -12952,7 +14294,7 @@
               <a:buNone/>
             </a:pPr>
             <a:r>
-              <a:rPr lang="en-US" sz="600" b="1" spc="30" kern="0" dirty="0">
+              <a:rPr lang="en-US" sz="540" b="1" spc="30" kern="0" dirty="0">
                 <a:solidFill>
                   <a:srgbClr val="557DC0"/>
                 </a:solidFill>
@@ -12960,225 +14302,15 @@
                 <a:ea typeface="Aptos" pitchFamily="34" charset="-122"/>
                 <a:cs typeface="Aptos" pitchFamily="34" charset="-120"/>
               </a:rPr>
-              <a:t>EVIDENCE-FIRST</a:t>
-            </a:r>
-            <a:endParaRPr lang="en-US" sz="600" dirty="0"/>
-          </a:p>
-        </p:txBody>
-      </p:sp>
-      <p:sp>
-        <p:nvSpPr>
-          <p:cNvPr id="52" name="Shape 50"/>
-          <p:cNvSpPr/>
-          <p:nvPr/>
-        </p:nvSpPr>
-        <p:spPr>
-          <a:xfrm>
-            <a:off x="6553200" y="5257800"/>
-            <a:ext cx="1143000" cy="266700"/>
-          </a:xfrm>
-          <a:prstGeom prst="roundRect">
-            <a:avLst>
-              <a:gd name="adj" fmla="val 54857"/>
-            </a:avLst>
-          </a:prstGeom>
-          <a:solidFill>
-            <a:srgbClr val="FFF1DF"/>
-          </a:solidFill>
-          <a:ln w="6350">
-            <a:solidFill>
-              <a:srgbClr val="FFF1DF">
-                <a:alpha val="0"/>
-              </a:srgbClr>
-            </a:solidFill>
-            <a:prstDash val="solid"/>
-          </a:ln>
-        </p:spPr>
-      </p:sp>
-      <p:sp>
-        <p:nvSpPr>
-          <p:cNvPr id="53" name="Text 51"/>
-          <p:cNvSpPr txBox="1"/>
-          <p:nvPr/>
-        </p:nvSpPr>
-        <p:spPr>
-          <a:xfrm>
-            <a:off x="6629400" y="5280660"/>
-            <a:ext cx="990600" cy="220980"/>
-          </a:xfrm>
-          <a:prstGeom prst="rect">
-            <a:avLst/>
-          </a:prstGeom>
-          <a:noFill/>
-          <a:ln/>
-        </p:spPr>
-        <p:txBody>
-          <a:bodyPr wrap="square" lIns="0" tIns="0" rIns="0" bIns="0" rtlCol="0" anchor="ctr">
-            <a:normAutofit/>
-          </a:bodyPr>
-          <a:lstStyle/>
-          <a:p>
-            <a:pPr algn="ctr" indent="0" marL="0">
-              <a:buNone/>
-            </a:pPr>
-            <a:r>
-              <a:rPr lang="en-US" sz="600" b="1" spc="30" kern="0" dirty="0">
-                <a:solidFill>
-                  <a:srgbClr val="B87932"/>
-                </a:solidFill>
-                <a:latin typeface="Aptos" pitchFamily="34" charset="0"/>
-                <a:ea typeface="Aptos" pitchFamily="34" charset="-122"/>
-                <a:cs typeface="Aptos" pitchFamily="34" charset="-120"/>
-              </a:rPr>
-              <a:t>ASYNC JOBS</a:t>
-            </a:r>
-            <a:endParaRPr lang="en-US" sz="600" dirty="0"/>
-          </a:p>
-        </p:txBody>
-      </p:sp>
-      <p:sp>
-        <p:nvSpPr>
-          <p:cNvPr id="54" name="Shape 52"/>
-          <p:cNvSpPr/>
-          <p:nvPr/>
-        </p:nvSpPr>
-        <p:spPr>
-          <a:xfrm>
-            <a:off x="7810500" y="5257800"/>
-            <a:ext cx="1447800" cy="266700"/>
-          </a:xfrm>
-          <a:prstGeom prst="roundRect">
-            <a:avLst>
-              <a:gd name="adj" fmla="val 54857"/>
-            </a:avLst>
-          </a:prstGeom>
-          <a:solidFill>
-            <a:srgbClr val="EEE8F8"/>
-          </a:solidFill>
-          <a:ln w="6350">
-            <a:solidFill>
-              <a:srgbClr val="EEE8F8">
-                <a:alpha val="0"/>
-              </a:srgbClr>
-            </a:solidFill>
-            <a:prstDash val="solid"/>
-          </a:ln>
-        </p:spPr>
-      </p:sp>
-      <p:sp>
-        <p:nvSpPr>
-          <p:cNvPr id="55" name="Text 53"/>
-          <p:cNvSpPr txBox="1"/>
-          <p:nvPr/>
-        </p:nvSpPr>
-        <p:spPr>
-          <a:xfrm>
-            <a:off x="7886700" y="5280660"/>
-            <a:ext cx="1295400" cy="220980"/>
-          </a:xfrm>
-          <a:prstGeom prst="rect">
-            <a:avLst/>
-          </a:prstGeom>
-          <a:noFill/>
-          <a:ln/>
-        </p:spPr>
-        <p:txBody>
-          <a:bodyPr wrap="square" lIns="0" tIns="0" rIns="0" bIns="0" rtlCol="0" anchor="ctr">
-            <a:normAutofit/>
-          </a:bodyPr>
-          <a:lstStyle/>
-          <a:p>
-            <a:pPr algn="ctr" indent="0" marL="0">
-              <a:buNone/>
-            </a:pPr>
-            <a:r>
-              <a:rPr lang="en-US" sz="600" b="1" spc="30" kern="0" dirty="0">
-                <a:solidFill>
-                  <a:srgbClr val="7656A5"/>
-                </a:solidFill>
-                <a:latin typeface="Aptos" pitchFamily="34" charset="0"/>
-                <a:ea typeface="Aptos" pitchFamily="34" charset="-122"/>
-                <a:cs typeface="Aptos" pitchFamily="34" charset="-120"/>
-              </a:rPr>
-              <a:t>VERSIONED SCORES</a:t>
-            </a:r>
-            <a:endParaRPr lang="en-US" sz="600" dirty="0"/>
-          </a:p>
-        </p:txBody>
-      </p:sp>
-      <p:sp>
-        <p:nvSpPr>
-          <p:cNvPr id="56" name="Shape 54"/>
-          <p:cNvSpPr/>
-          <p:nvPr/>
-        </p:nvSpPr>
-        <p:spPr>
-          <a:xfrm>
-            <a:off x="9372600" y="5257800"/>
-            <a:ext cx="1333500" cy="266700"/>
-          </a:xfrm>
-          <a:prstGeom prst="roundRect">
-            <a:avLst>
-              <a:gd name="adj" fmla="val 54857"/>
-            </a:avLst>
-          </a:prstGeom>
-          <a:solidFill>
-            <a:srgbClr val="E4F2ED"/>
-          </a:solidFill>
-          <a:ln w="6350">
-            <a:solidFill>
-              <a:srgbClr val="E4F2ED">
-                <a:alpha val="0"/>
-              </a:srgbClr>
-            </a:solidFill>
-            <a:prstDash val="solid"/>
-          </a:ln>
-        </p:spPr>
-      </p:sp>
-      <p:sp>
-        <p:nvSpPr>
-          <p:cNvPr id="57" name="Text 55"/>
-          <p:cNvSpPr txBox="1"/>
-          <p:nvPr/>
-        </p:nvSpPr>
-        <p:spPr>
-          <a:xfrm>
-            <a:off x="9448800" y="5280660"/>
-            <a:ext cx="1181100" cy="220980"/>
-          </a:xfrm>
-          <a:prstGeom prst="rect">
-            <a:avLst/>
-          </a:prstGeom>
-          <a:noFill/>
-          <a:ln/>
-        </p:spPr>
-        <p:txBody>
-          <a:bodyPr wrap="square" lIns="0" tIns="0" rIns="0" bIns="0" rtlCol="0" anchor="ctr">
-            <a:normAutofit/>
-          </a:bodyPr>
-          <a:lstStyle/>
-          <a:p>
-            <a:pPr algn="ctr" indent="0" marL="0">
-              <a:buNone/>
-            </a:pPr>
-            <a:r>
-              <a:rPr lang="en-US" sz="600" b="1" spc="30" kern="0" dirty="0">
-                <a:solidFill>
-                  <a:srgbClr val="2F8B72"/>
-                </a:solidFill>
-                <a:latin typeface="Aptos" pitchFamily="34" charset="0"/>
-                <a:ea typeface="Aptos" pitchFamily="34" charset="-122"/>
-                <a:cs typeface="Aptos" pitchFamily="34" charset="-120"/>
-              </a:rPr>
-              <a:t>DOCKER-FIRST</a:t>
-            </a:r>
-            <a:endParaRPr lang="en-US" sz="600" dirty="0"/>
-          </a:p>
-        </p:txBody>
-      </p:sp>
-      <p:sp>
-        <p:nvSpPr>
-          <p:cNvPr id="58" name="Text 56"/>
+              <a:t>VERSIONED EVIDENCE</a:t>
+            </a:r>
+            <a:endParaRPr lang="en-US" sz="540" dirty="0"/>
+          </a:p>
+        </p:txBody>
+      </p:sp>
+      <p:sp>
+        <p:nvSpPr>
+          <p:cNvPr id="92" name="Text 90"/>
           <p:cNvSpPr/>
           <p:nvPr/>
         </p:nvSpPr>
@@ -13233,7 +14365,7 @@
       </p:sp>
       <p:sp>
         <p:nvSpPr>
-          <p:cNvPr id="59" name="Text 57"/>
+          <p:cNvPr id="93" name="Text 91"/>
           <p:cNvSpPr txBox="1"/>
           <p:nvPr/>
         </p:nvSpPr>
@@ -13472,141 +14604,6 @@
             <a:prstDash val="solid"/>
           </a:ln>
           <a:effectLst>
-            <a:outerShdw sx="100000" sy="100000" kx="0" ky="0" algn="bl" rotWithShape="0" blurRad="5.679133646942494e+57" dist="1.1358267293884988e+58" dir="3.526387384320001e+68">
-              <a:srgbClr val="405875">
-                <a:alpha val="1.2e+69"/>
-              </a:srgbClr>
-            </a:outerShdw>
-          </a:effectLst>
-        </p:spPr>
-      </p:sp>
-      <p:sp>
-        <p:nvSpPr>
-          <p:cNvPr id="6" name="Text 4"/>
-          <p:cNvSpPr txBox="1"/>
-          <p:nvPr/>
-        </p:nvSpPr>
-        <p:spPr>
-          <a:xfrm>
-            <a:off x="914400" y="2514600"/>
-            <a:ext cx="1676400" cy="502920"/>
-          </a:xfrm>
-          <a:prstGeom prst="rect">
-            <a:avLst/>
-          </a:prstGeom>
-          <a:noFill/>
-          <a:ln/>
-        </p:spPr>
-        <p:txBody>
-          <a:bodyPr wrap="square" lIns="0" tIns="0" rIns="0" bIns="0" rtlCol="0" anchor="ctr">
-            <a:normAutofit/>
-          </a:bodyPr>
-          <a:lstStyle/>
-          <a:p>
-            <a:pPr algn="l" indent="0" marL="0">
-              <a:buNone/>
-            </a:pPr>
-            <a:r>
-              <a:rPr lang="en-US" sz="3840" b="1" dirty="0">
-                <a:solidFill>
-                  <a:srgbClr val="2F8B72"/>
-                </a:solidFill>
-                <a:latin typeface="Aptos Display" pitchFamily="34" charset="0"/>
-                <a:ea typeface="Aptos Display" pitchFamily="34" charset="-122"/>
-                <a:cs typeface="Aptos Display" pitchFamily="34" charset="-120"/>
-              </a:rPr>
-              <a:t>10</a:t>
-            </a:r>
-            <a:endParaRPr lang="en-US" sz="3840" dirty="0"/>
-          </a:p>
-        </p:txBody>
-      </p:sp>
-      <p:sp>
-        <p:nvSpPr>
-          <p:cNvPr id="7" name="Text 5"/>
-          <p:cNvSpPr txBox="1"/>
-          <p:nvPr/>
-        </p:nvSpPr>
-        <p:spPr>
-          <a:xfrm>
-            <a:off x="914400" y="3162300"/>
-            <a:ext cx="1828800" cy="495300"/>
-          </a:xfrm>
-          <a:prstGeom prst="rect">
-            <a:avLst/>
-          </a:prstGeom>
-          <a:noFill/>
-          <a:ln/>
-        </p:spPr>
-        <p:txBody>
-          <a:bodyPr wrap="square" lIns="0" tIns="0" rIns="0" bIns="0" rtlCol="0" anchor="t">
-            <a:normAutofit/>
-          </a:bodyPr>
-          <a:lstStyle/>
-          <a:p>
-            <a:pPr algn="l" indent="0" marL="0">
-              <a:buNone/>
-            </a:pPr>
-            <a:r>
-              <a:rPr lang="en-US" sz="1200" b="1" dirty="0">
-                <a:solidFill>
-                  <a:srgbClr val="344258"/>
-                </a:solidFill>
-                <a:latin typeface="Aptos" pitchFamily="34" charset="0"/>
-                <a:ea typeface="Aptos" pitchFamily="34" charset="-122"/>
-                <a:cs typeface="Aptos" pitchFamily="34" charset="-120"/>
-              </a:rPr>
-              <a:t>public-source</a:t>
-            </a:r>
-            <a:endParaRPr lang="en-US" sz="1200" dirty="0"/>
-          </a:p>
-          <a:p>
-            <a:pPr algn="l" indent="0" marL="0">
-              <a:buNone/>
-            </a:pPr>
-            <a:r>
-              <a:rPr lang="en-US" sz="1200" b="1" dirty="0">
-                <a:solidFill>
-                  <a:srgbClr val="344258"/>
-                </a:solidFill>
-                <a:latin typeface="Aptos" pitchFamily="34" charset="0"/>
-                <a:ea typeface="Aptos" pitchFamily="34" charset="-122"/>
-                <a:cs typeface="Aptos" pitchFamily="34" charset="-120"/>
-              </a:rPr>
-              <a:t>collectors</a:t>
-            </a:r>
-            <a:endParaRPr lang="en-US" sz="1200" dirty="0"/>
-          </a:p>
-        </p:txBody>
-      </p:sp>
-      <p:sp>
-        <p:nvSpPr>
-          <p:cNvPr id="8" name="Shape 6"/>
-          <p:cNvSpPr/>
-          <p:nvPr/>
-        </p:nvSpPr>
-        <p:spPr>
-          <a:xfrm>
-            <a:off x="3505200" y="2286000"/>
-            <a:ext cx="2514600" cy="1790700"/>
-          </a:xfrm>
-          <a:prstGeom prst="roundRect">
-            <a:avLst>
-              <a:gd name="adj" fmla="val 9191"/>
-            </a:avLst>
-          </a:prstGeom>
-          <a:solidFill>
-            <a:srgbClr val="FFFFFF"/>
-          </a:solidFill>
-          <a:ln w="6350">
-            <a:solidFill>
-              <a:srgbClr val="FFFFFF">
-                <a:alpha val="0"/>
-              </a:srgbClr>
-            </a:solidFill>
-            <a:prstDash val="solid"/>
-          </a:ln>
-          <a:effectLst>
             <a:outerShdw sx="100000" sy="100000" kx="0" ky="0" algn="bl" rotWithShape="0" blurRad="7.212499731616968e+61" dist="1.4424999463233936e+62" dir="2.1158324305920003e+73">
               <a:srgbClr val="405875">
                 <a:alpha val="1.2e+74"/>
@@ -13617,13 +14614,13 @@
       </p:sp>
       <p:sp>
         <p:nvSpPr>
-          <p:cNvPr id="9" name="Text 7"/>
-          <p:cNvSpPr txBox="1"/>
-          <p:nvPr/>
-        </p:nvSpPr>
-        <p:spPr>
-          <a:xfrm>
-            <a:off x="3733800" y="2514600"/>
+          <p:cNvPr id="6" name="Text 4"/>
+          <p:cNvSpPr txBox="1"/>
+          <p:nvPr/>
+        </p:nvSpPr>
+        <p:spPr>
+          <a:xfrm>
+            <a:off x="914400" y="2514600"/>
             <a:ext cx="1676400" cy="502920"/>
           </a:xfrm>
           <a:prstGeom prst="rect">
@@ -13644,13 +14641,13 @@
             <a:r>
               <a:rPr lang="en-US" sz="3840" b="1" dirty="0">
                 <a:solidFill>
-                  <a:srgbClr val="557DC0"/>
+                  <a:srgbClr val="2F8B72"/>
                 </a:solidFill>
                 <a:latin typeface="Aptos Display" pitchFamily="34" charset="0"/>
                 <a:ea typeface="Aptos Display" pitchFamily="34" charset="-122"/>
                 <a:cs typeface="Aptos Display" pitchFamily="34" charset="-120"/>
               </a:rPr>
-              <a:t>112</a:t>
+              <a:t>10</a:t>
             </a:r>
             <a:endParaRPr lang="en-US" sz="3840" dirty="0"/>
           </a:p>
@@ -13658,13 +14655,13 @@
       </p:sp>
       <p:sp>
         <p:nvSpPr>
-          <p:cNvPr id="10" name="Text 8"/>
-          <p:cNvSpPr txBox="1"/>
-          <p:nvPr/>
-        </p:nvSpPr>
-        <p:spPr>
-          <a:xfrm>
-            <a:off x="3733800" y="3162300"/>
+          <p:cNvPr id="7" name="Text 5"/>
+          <p:cNvSpPr txBox="1"/>
+          <p:nvPr/>
+        </p:nvSpPr>
+        <p:spPr>
+          <a:xfrm>
+            <a:off x="914400" y="3162300"/>
             <a:ext cx="1828800" cy="495300"/>
           </a:xfrm>
           <a:prstGeom prst="rect">
@@ -13691,7 +14688,7 @@
                 <a:ea typeface="Aptos" pitchFamily="34" charset="-122"/>
                 <a:cs typeface="Aptos" pitchFamily="34" charset="-120"/>
               </a:rPr>
-              <a:t>persistent founder</a:t>
+              <a:t>public-source</a:t>
             </a:r>
             <a:endParaRPr lang="en-US" sz="1200" dirty="0"/>
           </a:p>
@@ -13708,7 +14705,7 @@
                 <a:ea typeface="Aptos" pitchFamily="34" charset="-122"/>
                 <a:cs typeface="Aptos" pitchFamily="34" charset="-120"/>
               </a:rPr>
-              <a:t>identities</a:t>
+              <a:t>collectors</a:t>
             </a:r>
             <a:endParaRPr lang="en-US" sz="1200" dirty="0"/>
           </a:p>
@@ -13716,13 +14713,13 @@
       </p:sp>
       <p:sp>
         <p:nvSpPr>
-          <p:cNvPr id="11" name="Shape 9"/>
-          <p:cNvSpPr/>
-          <p:nvPr/>
-        </p:nvSpPr>
-        <p:spPr>
-          <a:xfrm>
-            <a:off x="6324600" y="2286000"/>
+          <p:cNvPr id="8" name="Shape 6"/>
+          <p:cNvSpPr/>
+          <p:nvPr/>
+        </p:nvSpPr>
+        <p:spPr>
+          <a:xfrm>
+            <a:off x="3505200" y="2286000"/>
             <a:ext cx="2514600" cy="1790700"/>
           </a:xfrm>
           <a:prstGeom prst="roundRect">
@@ -13752,13 +14749,13 @@
       </p:sp>
       <p:sp>
         <p:nvSpPr>
-          <p:cNvPr id="12" name="Text 10"/>
-          <p:cNvSpPr txBox="1"/>
-          <p:nvPr/>
-        </p:nvSpPr>
-        <p:spPr>
-          <a:xfrm>
-            <a:off x="6553200" y="2514600"/>
+          <p:cNvPr id="9" name="Text 7"/>
+          <p:cNvSpPr txBox="1"/>
+          <p:nvPr/>
+        </p:nvSpPr>
+        <p:spPr>
+          <a:xfrm>
+            <a:off x="3733800" y="2514600"/>
             <a:ext cx="1676400" cy="502920"/>
           </a:xfrm>
           <a:prstGeom prst="rect">
@@ -13779,13 +14776,13 @@
             <a:r>
               <a:rPr lang="en-US" sz="3840" b="1" dirty="0">
                 <a:solidFill>
-                  <a:srgbClr val="7656A5"/>
+                  <a:srgbClr val="557DC0"/>
                 </a:solidFill>
                 <a:latin typeface="Aptos Display" pitchFamily="34" charset="0"/>
                 <a:ea typeface="Aptos Display" pitchFamily="34" charset="-122"/>
                 <a:cs typeface="Aptos Display" pitchFamily="34" charset="-120"/>
               </a:rPr>
-              <a:t>106</a:t>
+              <a:t>112</a:t>
             </a:r>
             <a:endParaRPr lang="en-US" sz="3840" dirty="0"/>
           </a:p>
@@ -13793,13 +14790,13 @@
       </p:sp>
       <p:sp>
         <p:nvSpPr>
-          <p:cNvPr id="13" name="Text 11"/>
-          <p:cNvSpPr txBox="1"/>
-          <p:nvPr/>
-        </p:nvSpPr>
-        <p:spPr>
-          <a:xfrm>
-            <a:off x="6553200" y="3162300"/>
+          <p:cNvPr id="10" name="Text 8"/>
+          <p:cNvSpPr txBox="1"/>
+          <p:nvPr/>
+        </p:nvSpPr>
+        <p:spPr>
+          <a:xfrm>
+            <a:off x="3733800" y="3162300"/>
             <a:ext cx="1828800" cy="495300"/>
           </a:xfrm>
           <a:prstGeom prst="rect">
@@ -13826,7 +14823,7 @@
                 <a:ea typeface="Aptos" pitchFamily="34" charset="-122"/>
                 <a:cs typeface="Aptos" pitchFamily="34" charset="-120"/>
               </a:rPr>
-              <a:t>automated</a:t>
+              <a:t>persistent founder</a:t>
             </a:r>
             <a:endParaRPr lang="en-US" sz="1200" dirty="0"/>
           </a:p>
@@ -13843,7 +14840,7 @@
                 <a:ea typeface="Aptos" pitchFamily="34" charset="-122"/>
                 <a:cs typeface="Aptos" pitchFamily="34" charset="-120"/>
               </a:rPr>
-              <a:t>tests passed</a:t>
+              <a:t>identities</a:t>
             </a:r>
             <a:endParaRPr lang="en-US" sz="1200" dirty="0"/>
           </a:p>
@@ -13851,13 +14848,13 @@
       </p:sp>
       <p:sp>
         <p:nvSpPr>
-          <p:cNvPr id="14" name="Shape 12"/>
-          <p:cNvSpPr/>
-          <p:nvPr/>
-        </p:nvSpPr>
-        <p:spPr>
-          <a:xfrm>
-            <a:off x="9144000" y="2286000"/>
+          <p:cNvPr id="11" name="Shape 9"/>
+          <p:cNvSpPr/>
+          <p:nvPr/>
+        </p:nvSpPr>
+        <p:spPr>
+          <a:xfrm>
+            <a:off x="6324600" y="2286000"/>
             <a:ext cx="2514600" cy="1790700"/>
           </a:xfrm>
           <a:prstGeom prst="roundRect">
@@ -13880,6 +14877,141 @@
             <a:outerShdw sx="100000" sy="100000" kx="0" ky="0" algn="bl" rotWithShape="0" blurRad="1.1633040817125008e+70" dist="2.3266081634250016e+70" dir="7.616996750131201e+82">
               <a:srgbClr val="405875">
                 <a:alpha val="1.2000000000000002e+84"/>
+              </a:srgbClr>
+            </a:outerShdw>
+          </a:effectLst>
+        </p:spPr>
+      </p:sp>
+      <p:sp>
+        <p:nvSpPr>
+          <p:cNvPr id="12" name="Text 10"/>
+          <p:cNvSpPr txBox="1"/>
+          <p:nvPr/>
+        </p:nvSpPr>
+        <p:spPr>
+          <a:xfrm>
+            <a:off x="6553200" y="2514600"/>
+            <a:ext cx="1676400" cy="502920"/>
+          </a:xfrm>
+          <a:prstGeom prst="rect">
+            <a:avLst/>
+          </a:prstGeom>
+          <a:noFill/>
+          <a:ln/>
+        </p:spPr>
+        <p:txBody>
+          <a:bodyPr wrap="square" lIns="0" tIns="0" rIns="0" bIns="0" rtlCol="0" anchor="ctr">
+            <a:normAutofit/>
+          </a:bodyPr>
+          <a:lstStyle/>
+          <a:p>
+            <a:pPr algn="l" indent="0" marL="0">
+              <a:buNone/>
+            </a:pPr>
+            <a:r>
+              <a:rPr lang="en-US" sz="3840" b="1" dirty="0">
+                <a:solidFill>
+                  <a:srgbClr val="7656A5"/>
+                </a:solidFill>
+                <a:latin typeface="Aptos Display" pitchFamily="34" charset="0"/>
+                <a:ea typeface="Aptos Display" pitchFamily="34" charset="-122"/>
+                <a:cs typeface="Aptos Display" pitchFamily="34" charset="-120"/>
+              </a:rPr>
+              <a:t>106</a:t>
+            </a:r>
+            <a:endParaRPr lang="en-US" sz="3840" dirty="0"/>
+          </a:p>
+        </p:txBody>
+      </p:sp>
+      <p:sp>
+        <p:nvSpPr>
+          <p:cNvPr id="13" name="Text 11"/>
+          <p:cNvSpPr txBox="1"/>
+          <p:nvPr/>
+        </p:nvSpPr>
+        <p:spPr>
+          <a:xfrm>
+            <a:off x="6553200" y="3162300"/>
+            <a:ext cx="1828800" cy="495300"/>
+          </a:xfrm>
+          <a:prstGeom prst="rect">
+            <a:avLst/>
+          </a:prstGeom>
+          <a:noFill/>
+          <a:ln/>
+        </p:spPr>
+        <p:txBody>
+          <a:bodyPr wrap="square" lIns="0" tIns="0" rIns="0" bIns="0" rtlCol="0" anchor="t">
+            <a:normAutofit/>
+          </a:bodyPr>
+          <a:lstStyle/>
+          <a:p>
+            <a:pPr algn="l" indent="0" marL="0">
+              <a:buNone/>
+            </a:pPr>
+            <a:r>
+              <a:rPr lang="en-US" sz="1200" b="1" dirty="0">
+                <a:solidFill>
+                  <a:srgbClr val="344258"/>
+                </a:solidFill>
+                <a:latin typeface="Aptos" pitchFamily="34" charset="0"/>
+                <a:ea typeface="Aptos" pitchFamily="34" charset="-122"/>
+                <a:cs typeface="Aptos" pitchFamily="34" charset="-120"/>
+              </a:rPr>
+              <a:t>automated</a:t>
+            </a:r>
+            <a:endParaRPr lang="en-US" sz="1200" dirty="0"/>
+          </a:p>
+          <a:p>
+            <a:pPr algn="l" indent="0" marL="0">
+              <a:buNone/>
+            </a:pPr>
+            <a:r>
+              <a:rPr lang="en-US" sz="1200" b="1" dirty="0">
+                <a:solidFill>
+                  <a:srgbClr val="344258"/>
+                </a:solidFill>
+                <a:latin typeface="Aptos" pitchFamily="34" charset="0"/>
+                <a:ea typeface="Aptos" pitchFamily="34" charset="-122"/>
+                <a:cs typeface="Aptos" pitchFamily="34" charset="-120"/>
+              </a:rPr>
+              <a:t>tests passed</a:t>
+            </a:r>
+            <a:endParaRPr lang="en-US" sz="1200" dirty="0"/>
+          </a:p>
+        </p:txBody>
+      </p:sp>
+      <p:sp>
+        <p:nvSpPr>
+          <p:cNvPr id="14" name="Shape 12"/>
+          <p:cNvSpPr/>
+          <p:nvPr/>
+        </p:nvSpPr>
+        <p:spPr>
+          <a:xfrm>
+            <a:off x="9144000" y="2286000"/>
+            <a:ext cx="2514600" cy="1790700"/>
+          </a:xfrm>
+          <a:prstGeom prst="roundRect">
+            <a:avLst>
+              <a:gd name="adj" fmla="val 9191"/>
+            </a:avLst>
+          </a:prstGeom>
+          <a:solidFill>
+            <a:srgbClr val="FFFFFF"/>
+          </a:solidFill>
+          <a:ln w="6350">
+            <a:solidFill>
+              <a:srgbClr val="FFFFFF">
+                <a:alpha val="0"/>
+              </a:srgbClr>
+            </a:solidFill>
+            <a:prstDash val="solid"/>
+          </a:ln>
+          <a:effectLst>
+            <a:outerShdw sx="100000" sy="100000" kx="0" ky="0" algn="bl" rotWithShape="0" blurRad="1.477396183774876e+74" dist="2.954792367549752e+74" dir="4.57019805007872e+87">
+              <a:srgbClr val="405875">
+                <a:alpha val="1.2000000000000002e+89"/>
               </a:srgbClr>
             </a:outerShdw>
           </a:effectLst>

</xml_diff>